<commit_message>
design: visually stunning, premium-grade asymmetric redesign of FHH PowerPoint presentation template
</commit_message>
<xml_diff>
--- a/public/Faith-Haven-House-Presentation-Template.pptx
+++ b/public/Faith-Haven-House-Presentation-Template.pptx
@@ -1506,8 +1506,28 @@
         </p:nvSpPr>
         <p:spPr>
           <a:xfrm>
-            <a:off x="0" y="5029200"/>
-            <a:ext cx="9144000" cy="114300"/>
+            <a:off x="0" y="0"/>
+            <a:ext cx="2926080" cy="5143500"/>
+          </a:xfrm>
+          <a:prstGeom prst="rect">
+            <a:avLst/>
+          </a:prstGeom>
+          <a:solidFill>
+            <a:srgbClr val="5C9EAD"/>
+          </a:solidFill>
+          <a:ln/>
+        </p:spPr>
+      </p:sp>
+      <p:sp>
+        <p:nvSpPr>
+          <p:cNvPr id="3" name="Shape 1"/>
+          <p:cNvSpPr/>
+          <p:nvPr/>
+        </p:nvSpPr>
+        <p:spPr>
+          <a:xfrm>
+            <a:off x="2926080" y="0"/>
+            <a:ext cx="73152" cy="5143500"/>
           </a:xfrm>
           <a:prstGeom prst="rect">
             <a:avLst/>
@@ -1520,14 +1540,14 @@
       </p:sp>
       <p:sp>
         <p:nvSpPr>
-          <p:cNvPr id="3" name="Text 1"/>
-          <p:cNvSpPr/>
-          <p:nvPr/>
-        </p:nvSpPr>
-        <p:spPr>
-          <a:xfrm>
-            <a:off x="914400" y="1097280"/>
-            <a:ext cx="7315200" cy="365760"/>
+          <p:cNvPr id="4" name="Text 2"/>
+          <p:cNvSpPr/>
+          <p:nvPr/>
+        </p:nvSpPr>
+        <p:spPr>
+          <a:xfrm>
+            <a:off x="3566160" y="1280160"/>
+            <a:ext cx="5029200" cy="365760"/>
           </a:xfrm>
           <a:prstGeom prst="rect">
             <a:avLst/>
@@ -1543,7 +1563,7 @@
               <a:buNone/>
             </a:pPr>
             <a:r>
-              <a:rPr lang="en-US" sz="1600" b="1" spc="400" kern="0" dirty="0">
+              <a:rPr lang="en-US" sz="1600" b="1" spc="500" kern="0" dirty="0">
                 <a:solidFill>
                   <a:srgbClr val="B8D8E8"/>
                 </a:solidFill>
@@ -1559,14 +1579,14 @@
       </p:sp>
       <p:sp>
         <p:nvSpPr>
-          <p:cNvPr id="4" name="Text 2"/>
-          <p:cNvSpPr/>
-          <p:nvPr/>
-        </p:nvSpPr>
-        <p:spPr>
-          <a:xfrm>
-            <a:off x="914400" y="1554480"/>
-            <a:ext cx="7315200" cy="1371600"/>
+          <p:cNvPr id="5" name="Text 3"/>
+          <p:cNvSpPr/>
+          <p:nvPr/>
+        </p:nvSpPr>
+        <p:spPr>
+          <a:xfrm>
+            <a:off x="3566160" y="1737360"/>
+            <a:ext cx="5029200" cy="1280160"/>
           </a:xfrm>
           <a:prstGeom prst="rect">
             <a:avLst/>
@@ -1598,14 +1618,14 @@
       </p:sp>
       <p:sp>
         <p:nvSpPr>
-          <p:cNvPr id="5" name="Text 3"/>
-          <p:cNvSpPr/>
-          <p:nvPr/>
-        </p:nvSpPr>
-        <p:spPr>
-          <a:xfrm>
-            <a:off x="914400" y="2926080"/>
-            <a:ext cx="7315200" cy="457200"/>
+          <p:cNvPr id="6" name="Text 4"/>
+          <p:cNvSpPr/>
+          <p:nvPr/>
+        </p:nvSpPr>
+        <p:spPr>
+          <a:xfrm>
+            <a:off x="3566160" y="3017520"/>
+            <a:ext cx="5029200" cy="457200"/>
           </a:xfrm>
           <a:prstGeom prst="rect">
             <a:avLst/>
@@ -1629,7 +1649,7 @@
                 <a:ea typeface="Calibri" pitchFamily="34" charset="-122"/>
                 <a:cs typeface="Calibri" pitchFamily="34" charset="-120"/>
               </a:rPr>
-              <a:t>Subheading or Presenter Name Goes Here</a:t>
+              <a:t>Branded Presentation System v1.0</a:t>
             </a:r>
             <a:endParaRPr lang="en-US" sz="1400" dirty="0"/>
           </a:p>
@@ -1637,7 +1657,7 @@
       </p:sp>
       <p:pic>
         <p:nvPicPr>
-          <p:cNvPr id="6" name="Image 0" descr="C:\Users\jlmil\OneDrive\Desktop\Faith Haven House\Faith Haven House Rebrand\fhh-website\public\assets\FHH-logo-clean.png">    </p:cNvPr>
+          <p:cNvPr id="7" name="Image 0" descr="C:\Users\jlmil\OneDrive\Desktop\Faith Haven House\Faith Haven House Rebrand\fhh-website\public\assets\FHH-logo-clean.png">    </p:cNvPr>
           <p:cNvPicPr>
             <a:picLocks noChangeAspect="1"/>
           </p:cNvPicPr>
@@ -1651,14 +1671,34 @@
         </p:blipFill>
         <p:spPr>
           <a:xfrm>
-            <a:off x="3566160" y="4023360"/>
-            <a:ext cx="2011680" cy="548640"/>
+            <a:off x="7680960" y="4206240"/>
+            <a:ext cx="1005840" cy="274320"/>
           </a:xfrm>
           <a:prstGeom prst="rect">
             <a:avLst/>
           </a:prstGeom>
         </p:spPr>
       </p:pic>
+      <p:sp>
+        <p:nvSpPr>
+          <p:cNvPr id="8" name="Shape 5"/>
+          <p:cNvSpPr/>
+          <p:nvPr/>
+        </p:nvSpPr>
+        <p:spPr>
+          <a:xfrm>
+            <a:off x="0" y="5029200"/>
+            <a:ext cx="9144000" cy="114300"/>
+          </a:xfrm>
+          <a:prstGeom prst="rect">
+            <a:avLst/>
+          </a:prstGeom>
+          <a:solidFill>
+            <a:srgbClr val="C86B4A"/>
+          </a:solidFill>
+          <a:ln/>
+        </p:spPr>
+      </p:sp>
     </p:spTree>
   </p:cSld>
   <p:clrMapOvr>
@@ -1699,8 +1739,28 @@
         </p:nvSpPr>
         <p:spPr>
           <a:xfrm>
-            <a:off x="0" y="5029200"/>
-            <a:ext cx="9144000" cy="114300"/>
+            <a:off x="0" y="0"/>
+            <a:ext cx="731520" cy="5143500"/>
+          </a:xfrm>
+          <a:prstGeom prst="rect">
+            <a:avLst/>
+          </a:prstGeom>
+          <a:solidFill>
+            <a:srgbClr val="294C60"/>
+          </a:solidFill>
+          <a:ln/>
+        </p:spPr>
+      </p:sp>
+      <p:sp>
+        <p:nvSpPr>
+          <p:cNvPr id="3" name="Shape 1"/>
+          <p:cNvSpPr/>
+          <p:nvPr/>
+        </p:nvSpPr>
+        <p:spPr>
+          <a:xfrm>
+            <a:off x="1371600" y="1920240"/>
+            <a:ext cx="1371600" cy="36576"/>
           </a:xfrm>
           <a:prstGeom prst="rect">
             <a:avLst/>
@@ -1713,14 +1773,14 @@
       </p:sp>
       <p:sp>
         <p:nvSpPr>
-          <p:cNvPr id="3" name="Text 1"/>
-          <p:cNvSpPr/>
-          <p:nvPr/>
-        </p:nvSpPr>
-        <p:spPr>
-          <a:xfrm>
-            <a:off x="914400" y="1371600"/>
-            <a:ext cx="7315200" cy="365760"/>
+          <p:cNvPr id="4" name="Text 2"/>
+          <p:cNvSpPr/>
+          <p:nvPr/>
+        </p:nvSpPr>
+        <p:spPr>
+          <a:xfrm>
+            <a:off x="1371600" y="1371600"/>
+            <a:ext cx="6400800" cy="365760"/>
           </a:xfrm>
           <a:prstGeom prst="rect">
             <a:avLst/>
@@ -1736,7 +1796,7 @@
               <a:buNone/>
             </a:pPr>
             <a:r>
-              <a:rPr lang="en-US" sz="1500" b="1" spc="400" kern="0" dirty="0">
+              <a:rPr lang="en-US" sz="1400" b="1" spc="400" kern="0" dirty="0">
                 <a:solidFill>
                   <a:srgbClr val="FAF8EF"/>
                 </a:solidFill>
@@ -1746,20 +1806,20 @@
               </a:rPr>
               <a:t>SECTION 01</a:t>
             </a:r>
-            <a:endParaRPr lang="en-US" sz="1500" dirty="0"/>
-          </a:p>
-        </p:txBody>
-      </p:sp>
-      <p:sp>
-        <p:nvSpPr>
-          <p:cNvPr id="4" name="Text 2"/>
-          <p:cNvSpPr/>
-          <p:nvPr/>
-        </p:nvSpPr>
-        <p:spPr>
-          <a:xfrm>
-            <a:off x="914400" y="1828800"/>
-            <a:ext cx="7315200" cy="1371600"/>
+            <a:endParaRPr lang="en-US" sz="1400" dirty="0"/>
+          </a:p>
+        </p:txBody>
+      </p:sp>
+      <p:sp>
+        <p:nvSpPr>
+          <p:cNvPr id="5" name="Text 3"/>
+          <p:cNvSpPr/>
+          <p:nvPr/>
+        </p:nvSpPr>
+        <p:spPr>
+          <a:xfrm>
+            <a:off x="1371600" y="2103120"/>
+            <a:ext cx="6858000" cy="1097280"/>
           </a:xfrm>
           <a:prstGeom prst="rect">
             <a:avLst/>
@@ -1791,14 +1851,14 @@
       </p:sp>
       <p:sp>
         <p:nvSpPr>
-          <p:cNvPr id="5" name="Text 3"/>
-          <p:cNvSpPr/>
-          <p:nvPr/>
-        </p:nvSpPr>
-        <p:spPr>
-          <a:xfrm>
-            <a:off x="914400" y="3200400"/>
-            <a:ext cx="7315200" cy="457200"/>
+          <p:cNvPr id="6" name="Text 4"/>
+          <p:cNvSpPr/>
+          <p:nvPr/>
+        </p:nvSpPr>
+        <p:spPr>
+          <a:xfrm>
+            <a:off x="1371600" y="3291840"/>
+            <a:ext cx="6858000" cy="365760"/>
           </a:xfrm>
           <a:prstGeom prst="rect">
             <a:avLst/>
@@ -1814,7 +1874,7 @@
               <a:buNone/>
             </a:pPr>
             <a:r>
-              <a:rPr lang="en-US" sz="1500" i="1" dirty="0">
+              <a:rPr lang="en-US" sz="1400" i="1" dirty="0">
                 <a:solidFill>
                   <a:srgbClr val="FAF8EF"/>
                 </a:solidFill>
@@ -1822,15 +1882,15 @@
                 <a:ea typeface="Calibri" pitchFamily="34" charset="-122"/>
                 <a:cs typeface="Calibri" pitchFamily="34" charset="-120"/>
               </a:rPr>
-              <a:t>Key milestones, candidate criteria, and committee timelines</a:t>
-            </a:r>
-            <a:endParaRPr lang="en-US" sz="1500" dirty="0"/>
+              <a:t>Milestones, criteria, and workflow guidelines</a:t>
+            </a:r>
+            <a:endParaRPr lang="en-US" sz="1400" dirty="0"/>
           </a:p>
         </p:txBody>
       </p:sp>
       <p:pic>
         <p:nvPicPr>
-          <p:cNvPr id="6" name="Image 0" descr="C:\Users\jlmil\OneDrive\Desktop\Faith Haven House\Faith Haven House Rebrand\fhh-website\public\assets\FHH-logo-clean.png">    </p:cNvPr>
+          <p:cNvPr id="7" name="Image 0" descr="C:\Users\jlmil\OneDrive\Desktop\Faith Haven House\Faith Haven House Rebrand\fhh-website\public\assets\FHH-logo-clean.png">    </p:cNvPr>
           <p:cNvPicPr>
             <a:picLocks noChangeAspect="1"/>
           </p:cNvPicPr>
@@ -1852,6 +1912,26 @@
           </a:prstGeom>
         </p:spPr>
       </p:pic>
+      <p:sp>
+        <p:nvSpPr>
+          <p:cNvPr id="8" name="Shape 5"/>
+          <p:cNvSpPr/>
+          <p:nvPr/>
+        </p:nvSpPr>
+        <p:spPr>
+          <a:xfrm>
+            <a:off x="0" y="5029200"/>
+            <a:ext cx="9144000" cy="114300"/>
+          </a:xfrm>
+          <a:prstGeom prst="rect">
+            <a:avLst/>
+          </a:prstGeom>
+          <a:solidFill>
+            <a:srgbClr val="C86B4A"/>
+          </a:solidFill>
+          <a:ln/>
+        </p:spPr>
+      </p:sp>
     </p:spTree>
   </p:cSld>
   <p:clrMapOvr>
@@ -1900,7 +1980,7 @@
         </p:blipFill>
         <p:spPr>
           <a:xfrm>
-            <a:off x="7772400" y="365760"/>
+            <a:off x="7772400" y="274320"/>
             <a:ext cx="1005840" cy="274320"/>
           </a:xfrm>
           <a:prstGeom prst="rect">
@@ -1916,8 +1996,42 @@
         </p:nvSpPr>
         <p:spPr>
           <a:xfrm>
-            <a:off x="731520" y="1188720"/>
-            <a:ext cx="73152" cy="2560320"/>
+            <a:off x="731520" y="731520"/>
+            <a:ext cx="7680960" cy="3657600"/>
+          </a:xfrm>
+          <a:prstGeom prst="roundRect">
+            <a:avLst>
+              <a:gd name="adj" fmla="val 2000"/>
+            </a:avLst>
+          </a:prstGeom>
+          <a:solidFill>
+            <a:srgbClr val="FFFFFF"/>
+          </a:solidFill>
+          <a:ln w="12700">
+            <a:solidFill>
+              <a:srgbClr val="E7ECEE"/>
+            </a:solidFill>
+            <a:prstDash val="solid"/>
+          </a:ln>
+          <a:effectLst>
+            <a:outerShdw sx="100000" sy="100000" kx="0" ky="0" algn="bl" rotWithShape="0" blurRad="152400" dist="38100" dir="8100000">
+              <a:srgbClr val="294C60">
+                <a:alpha val="6000"/>
+              </a:srgbClr>
+            </a:outerShdw>
+          </a:effectLst>
+        </p:spPr>
+      </p:sp>
+      <p:sp>
+        <p:nvSpPr>
+          <p:cNvPr id="4" name="Shape 1"/>
+          <p:cNvSpPr/>
+          <p:nvPr/>
+        </p:nvSpPr>
+        <p:spPr>
+          <a:xfrm>
+            <a:off x="731520" y="731520"/>
+            <a:ext cx="109728" cy="3657600"/>
           </a:xfrm>
           <a:prstGeom prst="rect">
             <a:avLst/>
@@ -1930,14 +2044,14 @@
       </p:sp>
       <p:sp>
         <p:nvSpPr>
-          <p:cNvPr id="4" name="Text 1"/>
-          <p:cNvSpPr/>
-          <p:nvPr/>
-        </p:nvSpPr>
-        <p:spPr>
-          <a:xfrm>
-            <a:off x="731520" y="457200"/>
-            <a:ext cx="6400800" cy="457200"/>
+          <p:cNvPr id="5" name="Text 2"/>
+          <p:cNvSpPr/>
+          <p:nvPr/>
+        </p:nvSpPr>
+        <p:spPr>
+          <a:xfrm>
+            <a:off x="1280160" y="1005840"/>
+            <a:ext cx="6400800" cy="365760"/>
           </a:xfrm>
           <a:prstGeom prst="rect">
             <a:avLst/>
@@ -1953,7 +2067,7 @@
               <a:buNone/>
             </a:pPr>
             <a:r>
-              <a:rPr lang="en-US" sz="2200" b="1" dirty="0">
+              <a:rPr lang="en-US" sz="2000" b="1" dirty="0">
                 <a:solidFill>
                   <a:srgbClr val="294C60"/>
                 </a:solidFill>
@@ -1963,20 +2077,20 @@
               </a:rPr>
               <a:t>Our Mission</a:t>
             </a:r>
-            <a:endParaRPr lang="en-US" sz="2200" dirty="0"/>
-          </a:p>
-        </p:txBody>
-      </p:sp>
-      <p:sp>
-        <p:nvSpPr>
-          <p:cNvPr id="5" name="Text 2"/>
-          <p:cNvSpPr/>
-          <p:nvPr/>
-        </p:nvSpPr>
-        <p:spPr>
-          <a:xfrm>
-            <a:off x="1005840" y="1280160"/>
-            <a:ext cx="6858000" cy="2011680"/>
+            <a:endParaRPr lang="en-US" sz="2000" dirty="0"/>
+          </a:p>
+        </p:txBody>
+      </p:sp>
+      <p:sp>
+        <p:nvSpPr>
+          <p:cNvPr id="6" name="Text 3"/>
+          <p:cNvSpPr/>
+          <p:nvPr/>
+        </p:nvSpPr>
+        <p:spPr>
+          <a:xfrm>
+            <a:off x="1188720" y="1188720"/>
+            <a:ext cx="914400" cy="914400"/>
           </a:xfrm>
           <a:prstGeom prst="rect">
             <a:avLst/>
@@ -1992,30 +2106,69 @@
               <a:buNone/>
             </a:pPr>
             <a:r>
-              <a:rPr lang="en-US" sz="2400" i="1" dirty="0">
-                <a:solidFill>
-                  <a:srgbClr val="27343B"/>
+              <a:rPr lang="en-US" sz="7200" dirty="0">
+                <a:solidFill>
+                  <a:srgbClr val="E8987A"/>
                 </a:solidFill>
                 <a:latin typeface="Georgia" pitchFamily="34" charset="0"/>
                 <a:ea typeface="Georgia" pitchFamily="34" charset="-122"/>
                 <a:cs typeface="Georgia" pitchFamily="34" charset="-120"/>
               </a:rPr>
+              <a:t>“</a:t>
+            </a:r>
+            <a:endParaRPr lang="en-US" sz="7200" dirty="0"/>
+          </a:p>
+        </p:txBody>
+      </p:sp>
+      <p:sp>
+        <p:nvSpPr>
+          <p:cNvPr id="7" name="Text 4"/>
+          <p:cNvSpPr/>
+          <p:nvPr/>
+        </p:nvSpPr>
+        <p:spPr>
+          <a:xfrm>
+            <a:off x="1280160" y="1645920"/>
+            <a:ext cx="6583680" cy="1645920"/>
+          </a:xfrm>
+          <a:prstGeom prst="rect">
+            <a:avLst/>
+          </a:prstGeom>
+          <a:noFill/>
+          <a:ln/>
+        </p:spPr>
+        <p:txBody>
+          <a:bodyPr wrap="square" rtlCol="0" anchor="ctr"/>
+          <a:lstStyle/>
+          <a:p>
+            <a:pPr indent="0" marL="0">
+              <a:buNone/>
+            </a:pPr>
+            <a:r>
+              <a:rPr lang="en-US" sz="2200" i="1" dirty="0">
+                <a:solidFill>
+                  <a:srgbClr val="27343B"/>
+                </a:solidFill>
+                <a:latin typeface="Georgia" pitchFamily="34" charset="0"/>
+                <a:ea typeface="Georgia" pitchFamily="34" charset="-122"/>
+                <a:cs typeface="Georgia" pitchFamily="34" charset="-120"/>
+              </a:rPr>
               <a:t>"To provide a safe, faith-centered environment that restores hope, fosters accountability, and equips individuals on their journey toward permanent housing and self-sufficiency."</a:t>
             </a:r>
-            <a:endParaRPr lang="en-US" sz="2400" dirty="0"/>
-          </a:p>
-        </p:txBody>
-      </p:sp>
-      <p:sp>
-        <p:nvSpPr>
-          <p:cNvPr id="6" name="Text 3"/>
-          <p:cNvSpPr/>
-          <p:nvPr/>
-        </p:nvSpPr>
-        <p:spPr>
-          <a:xfrm>
-            <a:off x="1005840" y="3383280"/>
-            <a:ext cx="6400800" cy="365760"/>
+            <a:endParaRPr lang="en-US" sz="2200" dirty="0"/>
+          </a:p>
+        </p:txBody>
+      </p:sp>
+      <p:sp>
+        <p:nvSpPr>
+          <p:cNvPr id="8" name="Text 5"/>
+          <p:cNvSpPr/>
+          <p:nvPr/>
+        </p:nvSpPr>
+        <p:spPr>
+          <a:xfrm>
+            <a:off x="1280160" y="3474720"/>
+            <a:ext cx="6583680" cy="365760"/>
           </a:xfrm>
           <a:prstGeom prst="rect">
             <a:avLst/>
@@ -2031,7 +2184,7 @@
               <a:buNone/>
             </a:pPr>
             <a:r>
-              <a:rPr lang="en-US" sz="1400" b="1" dirty="0">
+              <a:rPr lang="en-US" sz="1300" b="1" spc="200" kern="0" dirty="0">
                 <a:solidFill>
                   <a:srgbClr val="5C9EAD"/>
                 </a:solidFill>
@@ -2041,7 +2194,7 @@
               </a:rPr>
               <a:t>— Faith Haven House Guiding Principle</a:t>
             </a:r>
-            <a:endParaRPr lang="en-US" sz="1400" dirty="0"/>
+            <a:endParaRPr lang="en-US" sz="1300" dirty="0"/>
           </a:p>
         </p:txBody>
       </p:sp>
@@ -2093,7 +2246,7 @@
         </p:blipFill>
         <p:spPr>
           <a:xfrm>
-            <a:off x="7772400" y="365760"/>
+            <a:off x="7772400" y="274320"/>
             <a:ext cx="1005840" cy="274320"/>
           </a:xfrm>
           <a:prstGeom prst="rect">
@@ -2142,14 +2295,96 @@
       </p:sp>
       <p:sp>
         <p:nvSpPr>
-          <p:cNvPr id="4" name="Text 1"/>
+          <p:cNvPr id="4" name="Shape 1"/>
+          <p:cNvSpPr/>
+          <p:nvPr/>
+        </p:nvSpPr>
+        <p:spPr>
+          <a:xfrm>
+            <a:off x="4572000" y="1188720"/>
+            <a:ext cx="0" cy="3291840"/>
+          </a:xfrm>
+          <a:prstGeom prst="line">
+            <a:avLst/>
+          </a:prstGeom>
+          <a:noFill/>
+          <a:ln w="19050">
+            <a:solidFill>
+              <a:srgbClr val="B8D8E8"/>
+            </a:solidFill>
+            <a:prstDash val="dash"/>
+          </a:ln>
+        </p:spPr>
+      </p:sp>
+      <p:sp>
+        <p:nvSpPr>
+          <p:cNvPr id="5" name="Shape 2"/>
           <p:cNvSpPr/>
           <p:nvPr/>
         </p:nvSpPr>
         <p:spPr>
           <a:xfrm>
             <a:off x="731520" y="1097280"/>
-            <a:ext cx="3657600" cy="365760"/>
+            <a:ext cx="2194560" cy="365760"/>
+          </a:xfrm>
+          <a:prstGeom prst="rect">
+            <a:avLst/>
+          </a:prstGeom>
+          <a:solidFill>
+            <a:srgbClr val="294C60"/>
+          </a:solidFill>
+          <a:ln/>
+        </p:spPr>
+      </p:sp>
+      <p:sp>
+        <p:nvSpPr>
+          <p:cNvPr id="6" name="Text 3"/>
+          <p:cNvSpPr/>
+          <p:nvPr/>
+        </p:nvSpPr>
+        <p:spPr>
+          <a:xfrm>
+            <a:off x="731520" y="1097280"/>
+            <a:ext cx="2194560" cy="365760"/>
+          </a:xfrm>
+          <a:prstGeom prst="rect">
+            <a:avLst/>
+          </a:prstGeom>
+          <a:noFill/>
+          <a:ln/>
+        </p:spPr>
+        <p:txBody>
+          <a:bodyPr wrap="square" rtlCol="0" anchor="ctr"/>
+          <a:lstStyle/>
+          <a:p>
+            <a:pPr algn="ctr" indent="0" marL="0">
+              <a:buNone/>
+            </a:pPr>
+            <a:r>
+              <a:rPr lang="en-US" sz="1100" b="1" dirty="0">
+                <a:solidFill>
+                  <a:srgbClr val="FAF8EF"/>
+                </a:solidFill>
+                <a:latin typeface="Calibri" pitchFamily="34" charset="0"/>
+                <a:ea typeface="Calibri" pitchFamily="34" charset="-122"/>
+                <a:cs typeface="Calibri" pitchFamily="34" charset="-120"/>
+              </a:rPr>
+              <a:t>RESIDENT CARE</a:t>
+            </a:r>
+            <a:endParaRPr lang="en-US" sz="1100" dirty="0"/>
+          </a:p>
+        </p:txBody>
+      </p:sp>
+      <p:sp>
+        <p:nvSpPr>
+          <p:cNvPr id="7" name="Text 4"/>
+          <p:cNvSpPr/>
+          <p:nvPr/>
+        </p:nvSpPr>
+        <p:spPr>
+          <a:xfrm>
+            <a:off x="731520" y="1645920"/>
+            <a:ext cx="3474720" cy="365760"/>
           </a:xfrm>
           <a:prstGeom prst="rect">
             <a:avLst/>
@@ -2181,34 +2416,50 @@
       </p:sp>
       <p:sp>
         <p:nvSpPr>
-          <p:cNvPr id="5" name="Text 2"/>
-          <p:cNvSpPr/>
-          <p:nvPr/>
-        </p:nvSpPr>
-        <p:spPr>
-          <a:xfrm>
-            <a:off x="731520" y="1645920"/>
-            <a:ext cx="3657600" cy="2743200"/>
-          </a:xfrm>
-          <a:prstGeom prst="rect">
-            <a:avLst/>
-          </a:prstGeom>
-          <a:noFill/>
-          <a:ln/>
-        </p:spPr>
-        <p:txBody>
-          <a:bodyPr wrap="square" rtlCol="0" anchor="ctr"/>
-          <a:lstStyle/>
-          <a:p>
-            <a:pPr marL="342900" indent="-342900">
-              <a:spcAft>
-                <a:spcPts val="1200"/>
-              </a:spcAft>
-              <a:buSzPct val="100000"/>
-              <a:buChar char="•"/>
-            </a:pPr>
-            <a:r>
-              <a:rPr lang="en-US" sz="1400" dirty="0">
+          <p:cNvPr id="8" name="Shape 5"/>
+          <p:cNvSpPr/>
+          <p:nvPr/>
+        </p:nvSpPr>
+        <p:spPr>
+          <a:xfrm>
+            <a:off x="731520" y="2286000"/>
+            <a:ext cx="73152" cy="73152"/>
+          </a:xfrm>
+          <a:prstGeom prst="rect">
+            <a:avLst/>
+          </a:prstGeom>
+          <a:solidFill>
+            <a:srgbClr val="C86B4A"/>
+          </a:solidFill>
+          <a:ln/>
+        </p:spPr>
+      </p:sp>
+      <p:sp>
+        <p:nvSpPr>
+          <p:cNvPr id="9" name="Text 6"/>
+          <p:cNvSpPr/>
+          <p:nvPr/>
+        </p:nvSpPr>
+        <p:spPr>
+          <a:xfrm>
+            <a:off x="914400" y="2194560"/>
+            <a:ext cx="3291840" cy="365760"/>
+          </a:xfrm>
+          <a:prstGeom prst="rect">
+            <a:avLst/>
+          </a:prstGeom>
+          <a:noFill/>
+          <a:ln/>
+        </p:spPr>
+        <p:txBody>
+          <a:bodyPr wrap="square" rtlCol="0" anchor="ctr"/>
+          <a:lstStyle/>
+          <a:p>
+            <a:pPr indent="0" marL="0">
+              <a:buNone/>
+            </a:pPr>
+            <a:r>
+              <a:rPr lang="en-US" sz="1300" dirty="0">
                 <a:solidFill>
                   <a:srgbClr val="27343B"/>
                 </a:solidFill>
@@ -2218,18 +2469,56 @@
               </a:rPr>
               <a:t>Individual case management planning</a:t>
             </a:r>
-            <a:endParaRPr lang="en-US" sz="1400" dirty="0"/>
-          </a:p>
-          <a:p>
-            <a:pPr marL="342900" indent="-342900">
-              <a:spcAft>
-                <a:spcPts val="1200"/>
-              </a:spcAft>
-              <a:buSzPct val="100000"/>
-              <a:buChar char="•"/>
-            </a:pPr>
-            <a:r>
-              <a:rPr lang="en-US" sz="1400" dirty="0">
+            <a:endParaRPr lang="en-US" sz="1300" dirty="0"/>
+          </a:p>
+        </p:txBody>
+      </p:sp>
+      <p:sp>
+        <p:nvSpPr>
+          <p:cNvPr id="10" name="Shape 7"/>
+          <p:cNvSpPr/>
+          <p:nvPr/>
+        </p:nvSpPr>
+        <p:spPr>
+          <a:xfrm>
+            <a:off x="731520" y="2834640"/>
+            <a:ext cx="73152" cy="73152"/>
+          </a:xfrm>
+          <a:prstGeom prst="rect">
+            <a:avLst/>
+          </a:prstGeom>
+          <a:solidFill>
+            <a:srgbClr val="C86B4A"/>
+          </a:solidFill>
+          <a:ln/>
+        </p:spPr>
+      </p:sp>
+      <p:sp>
+        <p:nvSpPr>
+          <p:cNvPr id="11" name="Text 8"/>
+          <p:cNvSpPr/>
+          <p:nvPr/>
+        </p:nvSpPr>
+        <p:spPr>
+          <a:xfrm>
+            <a:off x="914400" y="2743200"/>
+            <a:ext cx="3291840" cy="365760"/>
+          </a:xfrm>
+          <a:prstGeom prst="rect">
+            <a:avLst/>
+          </a:prstGeom>
+          <a:noFill/>
+          <a:ln/>
+        </p:spPr>
+        <p:txBody>
+          <a:bodyPr wrap="square" rtlCol="0" anchor="ctr"/>
+          <a:lstStyle/>
+          <a:p>
+            <a:pPr indent="0" marL="0">
+              <a:buNone/>
+            </a:pPr>
+            <a:r>
+              <a:rPr lang="en-US" sz="1300" dirty="0">
                 <a:solidFill>
                   <a:srgbClr val="27343B"/>
                 </a:solidFill>
@@ -2237,20 +2526,58 @@
                 <a:ea typeface="Calibri" pitchFamily="34" charset="-122"/>
                 <a:cs typeface="Calibri" pitchFamily="34" charset="-120"/>
               </a:rPr>
-              <a:t>Mental health and behavioral counseling coordination</a:t>
-            </a:r>
-            <a:endParaRPr lang="en-US" sz="1400" dirty="0"/>
-          </a:p>
-          <a:p>
-            <a:pPr marL="342900" indent="-342900">
-              <a:spcAft>
-                <a:spcPts val="1200"/>
-              </a:spcAft>
-              <a:buSzPct val="100000"/>
-              <a:buChar char="•"/>
-            </a:pPr>
-            <a:r>
-              <a:rPr lang="en-US" sz="1400" dirty="0">
+              <a:t>Mental health &amp; counseling coordination</a:t>
+            </a:r>
+            <a:endParaRPr lang="en-US" sz="1300" dirty="0"/>
+          </a:p>
+        </p:txBody>
+      </p:sp>
+      <p:sp>
+        <p:nvSpPr>
+          <p:cNvPr id="12" name="Shape 9"/>
+          <p:cNvSpPr/>
+          <p:nvPr/>
+        </p:nvSpPr>
+        <p:spPr>
+          <a:xfrm>
+            <a:off x="731520" y="3383280"/>
+            <a:ext cx="73152" cy="73152"/>
+          </a:xfrm>
+          <a:prstGeom prst="rect">
+            <a:avLst/>
+          </a:prstGeom>
+          <a:solidFill>
+            <a:srgbClr val="C86B4A"/>
+          </a:solidFill>
+          <a:ln/>
+        </p:spPr>
+      </p:sp>
+      <p:sp>
+        <p:nvSpPr>
+          <p:cNvPr id="13" name="Text 10"/>
+          <p:cNvSpPr/>
+          <p:nvPr/>
+        </p:nvSpPr>
+        <p:spPr>
+          <a:xfrm>
+            <a:off x="914400" y="3291840"/>
+            <a:ext cx="3291840" cy="365760"/>
+          </a:xfrm>
+          <a:prstGeom prst="rect">
+            <a:avLst/>
+          </a:prstGeom>
+          <a:noFill/>
+          <a:ln/>
+        </p:spPr>
+        <p:txBody>
+          <a:bodyPr wrap="square" rtlCol="0" anchor="ctr"/>
+          <a:lstStyle/>
+          <a:p>
+            <a:pPr indent="0" marL="0">
+              <a:buNone/>
+            </a:pPr>
+            <a:r>
+              <a:rPr lang="en-US" sz="1300" dirty="0">
                 <a:solidFill>
                   <a:srgbClr val="27343B"/>
                 </a:solidFill>
@@ -2258,20 +2585,58 @@
                 <a:ea typeface="Calibri" pitchFamily="34" charset="-122"/>
                 <a:cs typeface="Calibri" pitchFamily="34" charset="-120"/>
               </a:rPr>
-              <a:t>Daily accountability structures and goal setting</a:t>
-            </a:r>
-            <a:endParaRPr lang="en-US" sz="1400" dirty="0"/>
-          </a:p>
-          <a:p>
-            <a:pPr marL="342900" indent="-342900">
-              <a:spcAft>
-                <a:spcPts val="1200"/>
-              </a:spcAft>
-              <a:buSzPct val="100000"/>
-              <a:buChar char="•"/>
-            </a:pPr>
-            <a:r>
-              <a:rPr lang="en-US" sz="1400" dirty="0">
+              <a:t>Daily accountability &amp; goal setting</a:t>
+            </a:r>
+            <a:endParaRPr lang="en-US" sz="1300" dirty="0"/>
+          </a:p>
+        </p:txBody>
+      </p:sp>
+      <p:sp>
+        <p:nvSpPr>
+          <p:cNvPr id="14" name="Shape 11"/>
+          <p:cNvSpPr/>
+          <p:nvPr/>
+        </p:nvSpPr>
+        <p:spPr>
+          <a:xfrm>
+            <a:off x="731520" y="3931920"/>
+            <a:ext cx="73152" cy="73152"/>
+          </a:xfrm>
+          <a:prstGeom prst="rect">
+            <a:avLst/>
+          </a:prstGeom>
+          <a:solidFill>
+            <a:srgbClr val="C86B4A"/>
+          </a:solidFill>
+          <a:ln/>
+        </p:spPr>
+      </p:sp>
+      <p:sp>
+        <p:nvSpPr>
+          <p:cNvPr id="15" name="Text 12"/>
+          <p:cNvSpPr/>
+          <p:nvPr/>
+        </p:nvSpPr>
+        <p:spPr>
+          <a:xfrm>
+            <a:off x="914400" y="3840480"/>
+            <a:ext cx="3291840" cy="365760"/>
+          </a:xfrm>
+          <a:prstGeom prst="rect">
+            <a:avLst/>
+          </a:prstGeom>
+          <a:noFill/>
+          <a:ln/>
+        </p:spPr>
+        <p:txBody>
+          <a:bodyPr wrap="square" rtlCol="0" anchor="ctr"/>
+          <a:lstStyle/>
+          <a:p>
+            <a:pPr indent="0" marL="0">
+              <a:buNone/>
+            </a:pPr>
+            <a:r>
+              <a:rPr lang="en-US" sz="1300" dirty="0">
                 <a:solidFill>
                   <a:srgbClr val="27343B"/>
                 </a:solidFill>
@@ -2279,22 +2644,81 @@
                 <a:ea typeface="Calibri" pitchFamily="34" charset="-122"/>
                 <a:cs typeface="Calibri" pitchFamily="34" charset="-120"/>
               </a:rPr>
-              <a:t>Skill-building classes and community service</a:t>
-            </a:r>
-            <a:endParaRPr lang="en-US" sz="1400" dirty="0"/>
-          </a:p>
-        </p:txBody>
-      </p:sp>
-      <p:sp>
-        <p:nvSpPr>
-          <p:cNvPr id="6" name="Text 3"/>
-          <p:cNvSpPr/>
-          <p:nvPr/>
-        </p:nvSpPr>
-        <p:spPr>
-          <a:xfrm>
-            <a:off x="4754880" y="1097280"/>
-            <a:ext cx="3657600" cy="365760"/>
+              <a:t>Skill-building &amp; community service</a:t>
+            </a:r>
+            <a:endParaRPr lang="en-US" sz="1300" dirty="0"/>
+          </a:p>
+        </p:txBody>
+      </p:sp>
+      <p:sp>
+        <p:nvSpPr>
+          <p:cNvPr id="16" name="Shape 13"/>
+          <p:cNvSpPr/>
+          <p:nvPr/>
+        </p:nvSpPr>
+        <p:spPr>
+          <a:xfrm>
+            <a:off x="4937760" y="1097280"/>
+            <a:ext cx="2194560" cy="365760"/>
+          </a:xfrm>
+          <a:prstGeom prst="rect">
+            <a:avLst/>
+          </a:prstGeom>
+          <a:solidFill>
+            <a:srgbClr val="5C9EAD"/>
+          </a:solidFill>
+          <a:ln/>
+        </p:spPr>
+      </p:sp>
+      <p:sp>
+        <p:nvSpPr>
+          <p:cNvPr id="17" name="Text 14"/>
+          <p:cNvSpPr/>
+          <p:nvPr/>
+        </p:nvSpPr>
+        <p:spPr>
+          <a:xfrm>
+            <a:off x="4937760" y="1097280"/>
+            <a:ext cx="2194560" cy="365760"/>
+          </a:xfrm>
+          <a:prstGeom prst="rect">
+            <a:avLst/>
+          </a:prstGeom>
+          <a:noFill/>
+          <a:ln/>
+        </p:spPr>
+        <p:txBody>
+          <a:bodyPr wrap="square" rtlCol="0" anchor="ctr"/>
+          <a:lstStyle/>
+          <a:p>
+            <a:pPr algn="ctr" indent="0" marL="0">
+              <a:buNone/>
+            </a:pPr>
+            <a:r>
+              <a:rPr lang="en-US" sz="1100" b="1" dirty="0">
+                <a:solidFill>
+                  <a:srgbClr val="FAF8EF"/>
+                </a:solidFill>
+                <a:latin typeface="Calibri" pitchFamily="34" charset="0"/>
+                <a:ea typeface="Calibri" pitchFamily="34" charset="-122"/>
+                <a:cs typeface="Calibri" pitchFamily="34" charset="-120"/>
+              </a:rPr>
+              <a:t>ADMISSIONS</a:t>
+            </a:r>
+            <a:endParaRPr lang="en-US" sz="1100" dirty="0"/>
+          </a:p>
+        </p:txBody>
+      </p:sp>
+      <p:sp>
+        <p:nvSpPr>
+          <p:cNvPr id="18" name="Text 15"/>
+          <p:cNvSpPr/>
+          <p:nvPr/>
+        </p:nvSpPr>
+        <p:spPr>
+          <a:xfrm>
+            <a:off x="4937760" y="1645920"/>
+            <a:ext cx="3474720" cy="365760"/>
           </a:xfrm>
           <a:prstGeom prst="rect">
             <a:avLst/>
@@ -2312,7 +2736,7 @@
             <a:r>
               <a:rPr lang="en-US" sz="1800" b="1" dirty="0">
                 <a:solidFill>
-                  <a:srgbClr val="5C9EAD"/>
+                  <a:srgbClr val="294C60"/>
                 </a:solidFill>
                 <a:latin typeface="Georgia" pitchFamily="34" charset="0"/>
                 <a:ea typeface="Georgia" pitchFamily="34" charset="-122"/>
@@ -2326,34 +2750,50 @@
       </p:sp>
       <p:sp>
         <p:nvSpPr>
-          <p:cNvPr id="7" name="Text 4"/>
-          <p:cNvSpPr/>
-          <p:nvPr/>
-        </p:nvSpPr>
-        <p:spPr>
-          <a:xfrm>
-            <a:off x="4754880" y="1645920"/>
-            <a:ext cx="3657600" cy="2743200"/>
-          </a:xfrm>
-          <a:prstGeom prst="rect">
-            <a:avLst/>
-          </a:prstGeom>
-          <a:noFill/>
-          <a:ln/>
-        </p:spPr>
-        <p:txBody>
-          <a:bodyPr wrap="square" rtlCol="0" anchor="ctr"/>
-          <a:lstStyle/>
-          <a:p>
-            <a:pPr marL="342900" indent="-342900">
-              <a:spcAft>
-                <a:spcPts val="1200"/>
-              </a:spcAft>
-              <a:buSzPct val="100000"/>
-              <a:buChar char="•"/>
-            </a:pPr>
-            <a:r>
-              <a:rPr lang="en-US" sz="1400" dirty="0">
+          <p:cNvPr id="19" name="Shape 16"/>
+          <p:cNvSpPr/>
+          <p:nvPr/>
+        </p:nvSpPr>
+        <p:spPr>
+          <a:xfrm>
+            <a:off x="4937760" y="2286000"/>
+            <a:ext cx="73152" cy="73152"/>
+          </a:xfrm>
+          <a:prstGeom prst="rect">
+            <a:avLst/>
+          </a:prstGeom>
+          <a:solidFill>
+            <a:srgbClr val="C86B4A"/>
+          </a:solidFill>
+          <a:ln/>
+        </p:spPr>
+      </p:sp>
+      <p:sp>
+        <p:nvSpPr>
+          <p:cNvPr id="20" name="Text 17"/>
+          <p:cNvSpPr/>
+          <p:nvPr/>
+        </p:nvSpPr>
+        <p:spPr>
+          <a:xfrm>
+            <a:off x="5120640" y="2194560"/>
+            <a:ext cx="3291840" cy="365760"/>
+          </a:xfrm>
+          <a:prstGeom prst="rect">
+            <a:avLst/>
+          </a:prstGeom>
+          <a:noFill/>
+          <a:ln/>
+        </p:spPr>
+        <p:txBody>
+          <a:bodyPr wrap="square" rtlCol="0" anchor="ctr"/>
+          <a:lstStyle/>
+          <a:p>
+            <a:pPr indent="0" marL="0">
+              <a:buNone/>
+            </a:pPr>
+            <a:r>
+              <a:rPr lang="en-US" sz="1300" dirty="0">
                 <a:solidFill>
                   <a:srgbClr val="27343B"/>
                 </a:solidFill>
@@ -2361,20 +2801,58 @@
                 <a:ea typeface="Calibri" pitchFamily="34" charset="-122"/>
                 <a:cs typeface="Calibri" pitchFamily="34" charset="-120"/>
               </a:rPr>
-              <a:t>Multi-stage pre-screening and readiness review</a:t>
-            </a:r>
-            <a:endParaRPr lang="en-US" sz="1400" dirty="0"/>
-          </a:p>
-          <a:p>
-            <a:pPr marL="342900" indent="-342900">
-              <a:spcAft>
-                <a:spcPts val="1200"/>
-              </a:spcAft>
-              <a:buSzPct val="100000"/>
-              <a:buChar char="•"/>
-            </a:pPr>
-            <a:r>
-              <a:rPr lang="en-US" sz="1400" dirty="0">
+              <a:t>Multi-stage pre-screening reviews</a:t>
+            </a:r>
+            <a:endParaRPr lang="en-US" sz="1300" dirty="0"/>
+          </a:p>
+        </p:txBody>
+      </p:sp>
+      <p:sp>
+        <p:nvSpPr>
+          <p:cNvPr id="21" name="Shape 18"/>
+          <p:cNvSpPr/>
+          <p:nvPr/>
+        </p:nvSpPr>
+        <p:spPr>
+          <a:xfrm>
+            <a:off x="4937760" y="2834640"/>
+            <a:ext cx="73152" cy="73152"/>
+          </a:xfrm>
+          <a:prstGeom prst="rect">
+            <a:avLst/>
+          </a:prstGeom>
+          <a:solidFill>
+            <a:srgbClr val="C86B4A"/>
+          </a:solidFill>
+          <a:ln/>
+        </p:spPr>
+      </p:sp>
+      <p:sp>
+        <p:nvSpPr>
+          <p:cNvPr id="22" name="Text 19"/>
+          <p:cNvSpPr/>
+          <p:nvPr/>
+        </p:nvSpPr>
+        <p:spPr>
+          <a:xfrm>
+            <a:off x="5120640" y="2743200"/>
+            <a:ext cx="3291840" cy="365760"/>
+          </a:xfrm>
+          <a:prstGeom prst="rect">
+            <a:avLst/>
+          </a:prstGeom>
+          <a:noFill/>
+          <a:ln/>
+        </p:spPr>
+        <p:txBody>
+          <a:bodyPr wrap="square" rtlCol="0" anchor="ctr"/>
+          <a:lstStyle/>
+          <a:p>
+            <a:pPr indent="0" marL="0">
+              <a:buNone/>
+            </a:pPr>
+            <a:r>
+              <a:rPr lang="en-US" sz="1300" dirty="0">
                 <a:solidFill>
                   <a:srgbClr val="27343B"/>
                 </a:solidFill>
@@ -2382,20 +2860,58 @@
                 <a:ea typeface="Calibri" pitchFamily="34" charset="-122"/>
                 <a:cs typeface="Calibri" pitchFamily="34" charset="-120"/>
               </a:rPr>
-              <a:t>Structured welcome day process for new arrivals</a:t>
-            </a:r>
-            <a:endParaRPr lang="en-US" sz="1400" dirty="0"/>
-          </a:p>
-          <a:p>
-            <a:pPr marL="342900" indent="-342900">
-              <a:spcAft>
-                <a:spcPts val="1200"/>
-              </a:spcAft>
-              <a:buSzPct val="100000"/>
-              <a:buChar char="•"/>
-            </a:pPr>
-            <a:r>
-              <a:rPr lang="en-US" sz="1400" dirty="0">
+              <a:t>Structured welcome day check-in</a:t>
+            </a:r>
+            <a:endParaRPr lang="en-US" sz="1300" dirty="0"/>
+          </a:p>
+        </p:txBody>
+      </p:sp>
+      <p:sp>
+        <p:nvSpPr>
+          <p:cNvPr id="23" name="Shape 20"/>
+          <p:cNvSpPr/>
+          <p:nvPr/>
+        </p:nvSpPr>
+        <p:spPr>
+          <a:xfrm>
+            <a:off x="4937760" y="3383280"/>
+            <a:ext cx="73152" cy="73152"/>
+          </a:xfrm>
+          <a:prstGeom prst="rect">
+            <a:avLst/>
+          </a:prstGeom>
+          <a:solidFill>
+            <a:srgbClr val="C86B4A"/>
+          </a:solidFill>
+          <a:ln/>
+        </p:spPr>
+      </p:sp>
+      <p:sp>
+        <p:nvSpPr>
+          <p:cNvPr id="24" name="Text 21"/>
+          <p:cNvSpPr/>
+          <p:nvPr/>
+        </p:nvSpPr>
+        <p:spPr>
+          <a:xfrm>
+            <a:off x="5120640" y="3291840"/>
+            <a:ext cx="3291840" cy="365760"/>
+          </a:xfrm>
+          <a:prstGeom prst="rect">
+            <a:avLst/>
+          </a:prstGeom>
+          <a:noFill/>
+          <a:ln/>
+        </p:spPr>
+        <p:txBody>
+          <a:bodyPr wrap="square" rtlCol="0" anchor="ctr"/>
+          <a:lstStyle/>
+          <a:p>
+            <a:pPr indent="0" marL="0">
+              <a:buNone/>
+            </a:pPr>
+            <a:r>
+              <a:rPr lang="en-US" sz="1300" dirty="0">
                 <a:solidFill>
                   <a:srgbClr val="27343B"/>
                 </a:solidFill>
@@ -2403,20 +2919,58 @@
                 <a:ea typeface="Calibri" pitchFamily="34" charset="-122"/>
                 <a:cs typeface="Calibri" pitchFamily="34" charset="-120"/>
               </a:rPr>
-              <a:t>Transition planning to permanent housing</a:t>
-            </a:r>
-            <a:endParaRPr lang="en-US" sz="1400" dirty="0"/>
-          </a:p>
-          <a:p>
-            <a:pPr marL="342900" indent="-342900">
-              <a:spcAft>
-                <a:spcPts val="1200"/>
-              </a:spcAft>
-              <a:buSzPct val="100000"/>
-              <a:buChar char="•"/>
-            </a:pPr>
-            <a:r>
-              <a:rPr lang="en-US" sz="1400" dirty="0">
+              <a:t>Transition housing preparation</a:t>
+            </a:r>
+            <a:endParaRPr lang="en-US" sz="1300" dirty="0"/>
+          </a:p>
+        </p:txBody>
+      </p:sp>
+      <p:sp>
+        <p:nvSpPr>
+          <p:cNvPr id="25" name="Shape 22"/>
+          <p:cNvSpPr/>
+          <p:nvPr/>
+        </p:nvSpPr>
+        <p:spPr>
+          <a:xfrm>
+            <a:off x="4937760" y="3931920"/>
+            <a:ext cx="73152" cy="73152"/>
+          </a:xfrm>
+          <a:prstGeom prst="rect">
+            <a:avLst/>
+          </a:prstGeom>
+          <a:solidFill>
+            <a:srgbClr val="C86B4A"/>
+          </a:solidFill>
+          <a:ln/>
+        </p:spPr>
+      </p:sp>
+      <p:sp>
+        <p:nvSpPr>
+          <p:cNvPr id="26" name="Text 23"/>
+          <p:cNvSpPr/>
+          <p:nvPr/>
+        </p:nvSpPr>
+        <p:spPr>
+          <a:xfrm>
+            <a:off x="5120640" y="3840480"/>
+            <a:ext cx="3291840" cy="365760"/>
+          </a:xfrm>
+          <a:prstGeom prst="rect">
+            <a:avLst/>
+          </a:prstGeom>
+          <a:noFill/>
+          <a:ln/>
+        </p:spPr>
+        <p:txBody>
+          <a:bodyPr wrap="square" rtlCol="0" anchor="ctr"/>
+          <a:lstStyle/>
+          <a:p>
+            <a:pPr indent="0" marL="0">
+              <a:buNone/>
+            </a:pPr>
+            <a:r>
+              <a:rPr lang="en-US" sz="1300" dirty="0">
                 <a:solidFill>
                   <a:srgbClr val="27343B"/>
                 </a:solidFill>
@@ -2424,9 +2978,9 @@
                 <a:ea typeface="Calibri" pitchFamily="34" charset="-122"/>
                 <a:cs typeface="Calibri" pitchFamily="34" charset="-120"/>
               </a:rPr>
-              <a:t>Active donor and community engagement</a:t>
-            </a:r>
-            <a:endParaRPr lang="en-US" sz="1400" dirty="0"/>
+              <a:t>Community donor collaborations</a:t>
+            </a:r>
+            <a:endParaRPr lang="en-US" sz="1300" dirty="0"/>
           </a:p>
         </p:txBody>
       </p:sp>
@@ -2478,7 +3032,7 @@
         </p:blipFill>
         <p:spPr>
           <a:xfrm>
-            <a:off x="7772400" y="365760"/>
+            <a:off x="7772400" y="274320"/>
             <a:ext cx="1005840" cy="274320"/>
           </a:xfrm>
           <a:prstGeom prst="rect">
@@ -2527,14 +3081,61 @@
       </p:sp>
       <p:sp>
         <p:nvSpPr>
-          <p:cNvPr id="4" name="Text 1"/>
+          <p:cNvPr id="4" name="Shape 1"/>
           <p:cNvSpPr/>
           <p:nvPr/>
         </p:nvSpPr>
         <p:spPr>
           <a:xfrm>
             <a:off x="731520" y="1097280"/>
-            <a:ext cx="3840480" cy="914400"/>
+            <a:ext cx="3840480" cy="1554480"/>
+          </a:xfrm>
+          <a:prstGeom prst="roundRect">
+            <a:avLst>
+              <a:gd name="adj" fmla="val 4706"/>
+            </a:avLst>
+          </a:prstGeom>
+          <a:solidFill>
+            <a:srgbClr val="FFFFFF"/>
+          </a:solidFill>
+          <a:ln w="12700">
+            <a:solidFill>
+              <a:srgbClr val="E7ECEE"/>
+            </a:solidFill>
+            <a:prstDash val="solid"/>
+          </a:ln>
+        </p:spPr>
+      </p:sp>
+      <p:sp>
+        <p:nvSpPr>
+          <p:cNvPr id="5" name="Shape 2"/>
+          <p:cNvSpPr/>
+          <p:nvPr/>
+        </p:nvSpPr>
+        <p:spPr>
+          <a:xfrm>
+            <a:off x="731520" y="1097280"/>
+            <a:ext cx="73152" cy="1554480"/>
+          </a:xfrm>
+          <a:prstGeom prst="rect">
+            <a:avLst/>
+          </a:prstGeom>
+          <a:solidFill>
+            <a:srgbClr val="5C9EAD"/>
+          </a:solidFill>
+          <a:ln/>
+        </p:spPr>
+      </p:sp>
+      <p:sp>
+        <p:nvSpPr>
+          <p:cNvPr id="6" name="Text 3"/>
+          <p:cNvSpPr/>
+          <p:nvPr/>
+        </p:nvSpPr>
+        <p:spPr>
+          <a:xfrm>
+            <a:off x="1005840" y="1188720"/>
+            <a:ext cx="3383280" cy="274320"/>
           </a:xfrm>
           <a:prstGeom prst="rect">
             <a:avLst/>
@@ -2547,13 +3148,49 @@
           <a:lstStyle/>
           <a:p>
             <a:pPr indent="0" marL="0">
-              <a:spcAft>
-                <a:spcPts val="800"/>
-              </a:spcAft>
-              <a:buNone/>
-            </a:pPr>
-            <a:r>
-              <a:rPr lang="en-US" sz="1400" dirty="0">
+              <a:buNone/>
+            </a:pPr>
+            <a:r>
+              <a:rPr lang="en-US" sz="1400" b="1" dirty="0">
+                <a:solidFill>
+                  <a:srgbClr val="294C60"/>
+                </a:solidFill>
+                <a:latin typeface="Georgia" pitchFamily="34" charset="0"/>
+                <a:ea typeface="Georgia" pitchFamily="34" charset="-122"/>
+                <a:cs typeface="Georgia" pitchFamily="34" charset="-120"/>
+              </a:rPr>
+              <a:t>Initial Screening &amp; Suitability</a:t>
+            </a:r>
+            <a:endParaRPr lang="en-US" sz="1400" dirty="0"/>
+          </a:p>
+        </p:txBody>
+      </p:sp>
+      <p:sp>
+        <p:nvSpPr>
+          <p:cNvPr id="7" name="Text 4"/>
+          <p:cNvSpPr/>
+          <p:nvPr/>
+        </p:nvSpPr>
+        <p:spPr>
+          <a:xfrm>
+            <a:off x="1005840" y="1554480"/>
+            <a:ext cx="3383280" cy="1005840"/>
+          </a:xfrm>
+          <a:prstGeom prst="rect">
+            <a:avLst/>
+          </a:prstGeom>
+          <a:noFill/>
+          <a:ln/>
+        </p:spPr>
+        <p:txBody>
+          <a:bodyPr wrap="square" rtlCol="0" anchor="ctr"/>
+          <a:lstStyle/>
+          <a:p>
+            <a:pPr indent="0" marL="0">
+              <a:buNone/>
+            </a:pPr>
+            <a:r>
+              <a:rPr lang="en-US" sz="1100" dirty="0">
                 <a:solidFill>
                   <a:srgbClr val="27343B"/>
                 </a:solidFill>
@@ -2561,7 +3198,93 @@
                 <a:ea typeface="Calibri" pitchFamily="34" charset="-122"/>
                 <a:cs typeface="Calibri" pitchFamily="34" charset="-120"/>
               </a:rPr>
-              <a:t>Each applicant undergoes a structured assessment to ensure readiness and alignment with our residency standards. Our team works together to ensure proper fit.</a:t>
+              <a:t>Each applicant undergoes a structured background assessment and readiness review to ensure alignment with our residency standards.</a:t>
+            </a:r>
+            <a:endParaRPr lang="en-US" sz="1100" dirty="0"/>
+          </a:p>
+        </p:txBody>
+      </p:sp>
+      <p:sp>
+        <p:nvSpPr>
+          <p:cNvPr id="8" name="Shape 5"/>
+          <p:cNvSpPr/>
+          <p:nvPr/>
+        </p:nvSpPr>
+        <p:spPr>
+          <a:xfrm>
+            <a:off x="731520" y="2834640"/>
+            <a:ext cx="3840480" cy="1554480"/>
+          </a:xfrm>
+          <a:prstGeom prst="roundRect">
+            <a:avLst>
+              <a:gd name="adj" fmla="val 4706"/>
+            </a:avLst>
+          </a:prstGeom>
+          <a:solidFill>
+            <a:srgbClr val="FFFFFF"/>
+          </a:solidFill>
+          <a:ln w="12700">
+            <a:solidFill>
+              <a:srgbClr val="E7ECEE"/>
+            </a:solidFill>
+            <a:prstDash val="solid"/>
+          </a:ln>
+        </p:spPr>
+      </p:sp>
+      <p:sp>
+        <p:nvSpPr>
+          <p:cNvPr id="9" name="Shape 6"/>
+          <p:cNvSpPr/>
+          <p:nvPr/>
+        </p:nvSpPr>
+        <p:spPr>
+          <a:xfrm>
+            <a:off x="731520" y="2834640"/>
+            <a:ext cx="73152" cy="1554480"/>
+          </a:xfrm>
+          <a:prstGeom prst="rect">
+            <a:avLst/>
+          </a:prstGeom>
+          <a:solidFill>
+            <a:srgbClr val="C86B4A"/>
+          </a:solidFill>
+          <a:ln/>
+        </p:spPr>
+      </p:sp>
+      <p:sp>
+        <p:nvSpPr>
+          <p:cNvPr id="10" name="Text 7"/>
+          <p:cNvSpPr/>
+          <p:nvPr/>
+        </p:nvSpPr>
+        <p:spPr>
+          <a:xfrm>
+            <a:off x="1005840" y="2926080"/>
+            <a:ext cx="3383280" cy="274320"/>
+          </a:xfrm>
+          <a:prstGeom prst="rect">
+            <a:avLst/>
+          </a:prstGeom>
+          <a:noFill/>
+          <a:ln/>
+        </p:spPr>
+        <p:txBody>
+          <a:bodyPr wrap="square" rtlCol="0" anchor="ctr"/>
+          <a:lstStyle/>
+          <a:p>
+            <a:pPr indent="0" marL="0">
+              <a:buNone/>
+            </a:pPr>
+            <a:r>
+              <a:rPr lang="en-US" sz="1400" b="1" dirty="0">
+                <a:solidFill>
+                  <a:srgbClr val="294C60"/>
+                </a:solidFill>
+                <a:latin typeface="Georgia" pitchFamily="34" charset="0"/>
+                <a:ea typeface="Georgia" pitchFamily="34" charset="-122"/>
+                <a:cs typeface="Georgia" pitchFamily="34" charset="-120"/>
+              </a:rPr>
+              <a:t>Assessments &amp; Decision</a:t>
             </a:r>
             <a:endParaRPr lang="en-US" sz="1400" dirty="0"/>
           </a:p>
@@ -2569,34 +3292,30 @@
       </p:sp>
       <p:sp>
         <p:nvSpPr>
-          <p:cNvPr id="5" name="Text 2"/>
-          <p:cNvSpPr/>
-          <p:nvPr/>
-        </p:nvSpPr>
-        <p:spPr>
-          <a:xfrm>
-            <a:off x="731520" y="2194560"/>
-            <a:ext cx="3840480" cy="2011680"/>
-          </a:xfrm>
-          <a:prstGeom prst="rect">
-            <a:avLst/>
-          </a:prstGeom>
-          <a:noFill/>
-          <a:ln/>
-        </p:spPr>
-        <p:txBody>
-          <a:bodyPr wrap="square" rtlCol="0" anchor="ctr"/>
-          <a:lstStyle/>
-          <a:p>
-            <a:pPr marL="342900" indent="-342900">
-              <a:spcAft>
-                <a:spcPts val="1000"/>
-              </a:spcAft>
-              <a:buSzPct val="100000"/>
-              <a:buChar char="•"/>
-            </a:pPr>
-            <a:r>
-              <a:rPr lang="en-US" sz="1300" dirty="0">
+          <p:cNvPr id="11" name="Text 8"/>
+          <p:cNvSpPr/>
+          <p:nvPr/>
+        </p:nvSpPr>
+        <p:spPr>
+          <a:xfrm>
+            <a:off x="1005840" y="3291840"/>
+            <a:ext cx="3383280" cy="1005840"/>
+          </a:xfrm>
+          <a:prstGeom prst="rect">
+            <a:avLst/>
+          </a:prstGeom>
+          <a:noFill/>
+          <a:ln/>
+        </p:spPr>
+        <p:txBody>
+          <a:bodyPr wrap="square" rtlCol="0" anchor="ctr"/>
+          <a:lstStyle/>
+          <a:p>
+            <a:pPr indent="0" marL="0">
+              <a:buNone/>
+            </a:pPr>
+            <a:r>
+              <a:rPr lang="en-US" sz="1100" dirty="0">
                 <a:solidFill>
                   <a:srgbClr val="27343B"/>
                 </a:solidFill>
@@ -2604,78 +3323,15 @@
                 <a:ea typeface="Calibri" pitchFamily="34" charset="-122"/>
                 <a:cs typeface="Calibri" pitchFamily="34" charset="-120"/>
               </a:rPr>
-              <a:t>FHH 7.1 Interview Evaluation</a:t>
-            </a:r>
-            <a:endParaRPr lang="en-US" sz="1300" dirty="0"/>
-          </a:p>
-          <a:p>
-            <a:pPr marL="342900" indent="-342900">
-              <a:spcAft>
-                <a:spcPts val="1000"/>
-              </a:spcAft>
-              <a:buSzPct val="100000"/>
-              <a:buChar char="•"/>
-            </a:pPr>
-            <a:r>
-              <a:rPr lang="en-US" sz="1300" dirty="0">
-                <a:solidFill>
-                  <a:srgbClr val="27343B"/>
-                </a:solidFill>
-                <a:latin typeface="Calibri" pitchFamily="34" charset="0"/>
-                <a:ea typeface="Calibri" pitchFamily="34" charset="-122"/>
-                <a:cs typeface="Calibri" pitchFamily="34" charset="-120"/>
-              </a:rPr>
-              <a:t>FHH 7.2 Behavioral Health Assessment</a:t>
-            </a:r>
-            <a:endParaRPr lang="en-US" sz="1300" dirty="0"/>
-          </a:p>
-          <a:p>
-            <a:pPr marL="342900" indent="-342900">
-              <a:spcAft>
-                <a:spcPts val="1000"/>
-              </a:spcAft>
-              <a:buSzPct val="100000"/>
-              <a:buChar char="•"/>
-            </a:pPr>
-            <a:r>
-              <a:rPr lang="en-US" sz="1300" dirty="0">
-                <a:solidFill>
-                  <a:srgbClr val="27343B"/>
-                </a:solidFill>
-                <a:latin typeface="Calibri" pitchFamily="34" charset="0"/>
-                <a:ea typeface="Calibri" pitchFamily="34" charset="-122"/>
-                <a:cs typeface="Calibri" pitchFamily="34" charset="-120"/>
-              </a:rPr>
-              <a:t>FHH 7.3 Committee Decision Form</a:t>
-            </a:r>
-            <a:endParaRPr lang="en-US" sz="1300" dirty="0"/>
-          </a:p>
-          <a:p>
-            <a:pPr marL="342900" indent="-342900">
-              <a:spcAft>
-                <a:spcPts val="1000"/>
-              </a:spcAft>
-              <a:buSzPct val="100000"/>
-              <a:buChar char="•"/>
-            </a:pPr>
-            <a:r>
-              <a:rPr lang="en-US" sz="1300" dirty="0">
-                <a:solidFill>
-                  <a:srgbClr val="27343B"/>
-                </a:solidFill>
-                <a:latin typeface="Calibri" pitchFamily="34" charset="0"/>
-                <a:ea typeface="Calibri" pitchFamily="34" charset="-122"/>
-                <a:cs typeface="Calibri" pitchFamily="34" charset="-120"/>
-              </a:rPr>
-              <a:t>FHH 7.4 Welcome Day Preparation</a:t>
-            </a:r>
-            <a:endParaRPr lang="en-US" sz="1300" dirty="0"/>
-          </a:p>
-        </p:txBody>
-      </p:sp>
-      <p:sp>
-        <p:nvSpPr>
-          <p:cNvPr id="6" name="Shape 3"/>
+              <a:t>We utilize official checklists (FHH 7.1 through FHH 7.4) covering interview evaluation, behavioral readiness, and final committee approval.</a:t>
+            </a:r>
+            <a:endParaRPr lang="en-US" sz="1100" dirty="0"/>
+          </a:p>
+        </p:txBody>
+      </p:sp>
+      <p:sp>
+        <p:nvSpPr>
+          <p:cNvPr id="12" name="Shape 9"/>
           <p:cNvSpPr/>
           <p:nvPr/>
         </p:nvSpPr>
@@ -2690,26 +3346,116 @@
             </a:avLst>
           </a:prstGeom>
           <a:solidFill>
-            <a:srgbClr val="E7ECEE"/>
+            <a:srgbClr val="FFFFFF"/>
           </a:solidFill>
           <a:ln w="12700">
             <a:solidFill>
-              <a:srgbClr val="5C9EAD"/>
+              <a:srgbClr val="E7ECEE"/>
             </a:solidFill>
             <a:prstDash val="solid"/>
           </a:ln>
-        </p:spPr>
-      </p:sp>
-      <p:sp>
-        <p:nvSpPr>
-          <p:cNvPr id="7" name="Text 4"/>
-          <p:cNvSpPr/>
-          <p:nvPr/>
-        </p:nvSpPr>
-        <p:spPr>
-          <a:xfrm>
-            <a:off x="4937760" y="1097280"/>
-            <a:ext cx="3474720" cy="3291840"/>
+          <a:effectLst>
+            <a:outerShdw sx="100000" sy="100000" kx="0" ky="0" algn="bl" rotWithShape="0" blurRad="152400" dist="38100" dir="16200000">
+              <a:srgbClr val="294C60">
+                <a:alpha val="6000"/>
+              </a:srgbClr>
+            </a:outerShdw>
+          </a:effectLst>
+        </p:spPr>
+      </p:sp>
+      <p:sp>
+        <p:nvSpPr>
+          <p:cNvPr id="13" name="Shape 10"/>
+          <p:cNvSpPr/>
+          <p:nvPr/>
+        </p:nvSpPr>
+        <p:spPr>
+          <a:xfrm>
+            <a:off x="4937760" y="1463040"/>
+            <a:ext cx="3474720" cy="0"/>
+          </a:xfrm>
+          <a:prstGeom prst="line">
+            <a:avLst/>
+          </a:prstGeom>
+          <a:noFill/>
+          <a:ln w="12700">
+            <a:solidFill>
+              <a:srgbClr val="E7ECEE"/>
+            </a:solidFill>
+            <a:prstDash val="solid"/>
+          </a:ln>
+        </p:spPr>
+      </p:sp>
+      <p:sp>
+        <p:nvSpPr>
+          <p:cNvPr id="14" name="Shape 11"/>
+          <p:cNvSpPr/>
+          <p:nvPr/>
+        </p:nvSpPr>
+        <p:spPr>
+          <a:xfrm>
+            <a:off x="5120640" y="1234440"/>
+            <a:ext cx="91440" cy="91440"/>
+          </a:xfrm>
+          <a:prstGeom prst="ellipse">
+            <a:avLst/>
+          </a:prstGeom>
+          <a:solidFill>
+            <a:srgbClr val="C86B4A"/>
+          </a:solidFill>
+          <a:ln/>
+        </p:spPr>
+      </p:sp>
+      <p:sp>
+        <p:nvSpPr>
+          <p:cNvPr id="15" name="Shape 12"/>
+          <p:cNvSpPr/>
+          <p:nvPr/>
+        </p:nvSpPr>
+        <p:spPr>
+          <a:xfrm>
+            <a:off x="5257800" y="1234440"/>
+            <a:ext cx="91440" cy="91440"/>
+          </a:xfrm>
+          <a:prstGeom prst="ellipse">
+            <a:avLst/>
+          </a:prstGeom>
+          <a:solidFill>
+            <a:srgbClr val="B8D8E8"/>
+          </a:solidFill>
+          <a:ln/>
+        </p:spPr>
+      </p:sp>
+      <p:sp>
+        <p:nvSpPr>
+          <p:cNvPr id="16" name="Shape 13"/>
+          <p:cNvSpPr/>
+          <p:nvPr/>
+        </p:nvSpPr>
+        <p:spPr>
+          <a:xfrm>
+            <a:off x="5394960" y="1234440"/>
+            <a:ext cx="91440" cy="91440"/>
+          </a:xfrm>
+          <a:prstGeom prst="ellipse">
+            <a:avLst/>
+          </a:prstGeom>
+          <a:solidFill>
+            <a:srgbClr val="5C9EAD"/>
+          </a:solidFill>
+          <a:ln/>
+        </p:spPr>
+      </p:sp>
+      <p:sp>
+        <p:nvSpPr>
+          <p:cNvPr id="17" name="Text 14"/>
+          <p:cNvSpPr/>
+          <p:nvPr/>
+        </p:nvSpPr>
+        <p:spPr>
+          <a:xfrm>
+            <a:off x="5029200" y="1828800"/>
+            <a:ext cx="3291840" cy="365760"/>
           </a:xfrm>
           <a:prstGeom prst="rect">
             <a:avLst/>
@@ -2725,34 +3471,117 @@
               <a:buNone/>
             </a:pPr>
             <a:r>
-              <a:rPr lang="en-US" sz="1400" dirty="0">
-                <a:solidFill>
-                  <a:srgbClr val="5C9EAD"/>
+              <a:rPr lang="en-US" sz="1400" b="1" dirty="0">
+                <a:solidFill>
+                  <a:srgbClr val="294C60"/>
+                </a:solidFill>
+                <a:latin typeface="Georgia" pitchFamily="34" charset="0"/>
+                <a:ea typeface="Georgia" pitchFamily="34" charset="-122"/>
+                <a:cs typeface="Georgia" pitchFamily="34" charset="-120"/>
+              </a:rPr>
+              <a:t>Branded Image Mockup</a:t>
+            </a:r>
+            <a:endParaRPr lang="en-US" sz="1400" dirty="0"/>
+          </a:p>
+        </p:txBody>
+      </p:sp>
+      <p:sp>
+        <p:nvSpPr>
+          <p:cNvPr id="18" name="Text 15"/>
+          <p:cNvSpPr/>
+          <p:nvPr/>
+        </p:nvSpPr>
+        <p:spPr>
+          <a:xfrm>
+            <a:off x="5120640" y="2286000"/>
+            <a:ext cx="3108960" cy="914400"/>
+          </a:xfrm>
+          <a:prstGeom prst="rect">
+            <a:avLst/>
+          </a:prstGeom>
+          <a:noFill/>
+          <a:ln/>
+        </p:spPr>
+        <p:txBody>
+          <a:bodyPr wrap="square" rtlCol="0" anchor="ctr"/>
+          <a:lstStyle/>
+          <a:p>
+            <a:pPr algn="ctr" indent="0" marL="0">
+              <a:buNone/>
+            </a:pPr>
+            <a:r>
+              <a:rPr lang="en-US" sz="1100" dirty="0">
+                <a:solidFill>
+                  <a:srgbClr val="5E7890"/>
                 </a:solidFill>
                 <a:latin typeface="Calibri" pitchFamily="34" charset="0"/>
                 <a:ea typeface="Calibri" pitchFamily="34" charset="-122"/>
                 <a:cs typeface="Calibri" pitchFamily="34" charset="-120"/>
               </a:rPr>
-              <a:t>Branded Image Placeholder</a:t>
-            </a:r>
-            <a:endParaRPr lang="en-US" sz="1400" dirty="0"/>
-          </a:p>
+              <a:t>Insert Facility photo, roadmap graphic, or candidate evaluation flowchart inside this window container.</a:t>
+            </a:r>
+            <a:endParaRPr lang="en-US" sz="1100" dirty="0"/>
+          </a:p>
+        </p:txBody>
+      </p:sp>
+      <p:sp>
+        <p:nvSpPr>
+          <p:cNvPr id="19" name="Shape 16"/>
+          <p:cNvSpPr/>
+          <p:nvPr/>
+        </p:nvSpPr>
+        <p:spPr>
+          <a:xfrm>
+            <a:off x="5943600" y="3383280"/>
+            <a:ext cx="1463040" cy="365760"/>
+          </a:xfrm>
+          <a:prstGeom prst="roundRect">
+            <a:avLst>
+              <a:gd name="adj" fmla="val 15000"/>
+            </a:avLst>
+          </a:prstGeom>
+          <a:solidFill>
+            <a:srgbClr val="C86B4A"/>
+          </a:solidFill>
+          <a:ln/>
+        </p:spPr>
+      </p:sp>
+      <p:sp>
+        <p:nvSpPr>
+          <p:cNvPr id="20" name="Text 17"/>
+          <p:cNvSpPr/>
+          <p:nvPr/>
+        </p:nvSpPr>
+        <p:spPr>
+          <a:xfrm>
+            <a:off x="5943600" y="3383280"/>
+            <a:ext cx="1463040" cy="365760"/>
+          </a:xfrm>
+          <a:prstGeom prst="rect">
+            <a:avLst/>
+          </a:prstGeom>
+          <a:noFill/>
+          <a:ln/>
+        </p:spPr>
+        <p:txBody>
+          <a:bodyPr wrap="square" rtlCol="0" anchor="ctr"/>
+          <a:lstStyle/>
           <a:p>
             <a:pPr algn="ctr" indent="0" marL="0">
               <a:buNone/>
             </a:pPr>
             <a:r>
-              <a:rPr lang="en-US" sz="1400" dirty="0">
-                <a:solidFill>
-                  <a:srgbClr val="5C9EAD"/>
+              <a:rPr lang="en-US" sz="1000" b="1" dirty="0">
+                <a:solidFill>
+                  <a:srgbClr val="FAF8EF"/>
                 </a:solidFill>
                 <a:latin typeface="Calibri" pitchFamily="34" charset="0"/>
                 <a:ea typeface="Calibri" pitchFamily="34" charset="-122"/>
                 <a:cs typeface="Calibri" pitchFamily="34" charset="-120"/>
               </a:rPr>
-              <a:t>(Insert Team/Facility photo here)</a:t>
-            </a:r>
-            <a:endParaRPr lang="en-US" sz="1400" dirty="0"/>
+              <a:t>Upload Photo</a:t>
+            </a:r>
+            <a:endParaRPr lang="en-US" sz="1000" dirty="0"/>
           </a:p>
         </p:txBody>
       </p:sp>
@@ -2804,7 +3633,7 @@
         </p:blipFill>
         <p:spPr>
           <a:xfrm>
-            <a:off x="7772400" y="365760"/>
+            <a:off x="7772400" y="274320"/>
             <a:ext cx="1005840" cy="274320"/>
           </a:xfrm>
           <a:prstGeom prst="rect">
@@ -2859,19 +3688,30 @@
         </p:nvSpPr>
         <p:spPr>
           <a:xfrm>
-            <a:off x="914400" y="2560320"/>
-            <a:ext cx="7315200" cy="0"/>
-          </a:xfrm>
-          <a:prstGeom prst="line">
-            <a:avLst/>
-          </a:prstGeom>
-          <a:noFill/>
-          <a:ln w="38100">
+            <a:off x="731520" y="1188720"/>
+            <a:ext cx="1828800" cy="3291840"/>
+          </a:xfrm>
+          <a:prstGeom prst="roundRect">
+            <a:avLst>
+              <a:gd name="adj" fmla="val 4000"/>
+            </a:avLst>
+          </a:prstGeom>
+          <a:solidFill>
+            <a:srgbClr val="FFFFFF"/>
+          </a:solidFill>
+          <a:ln w="12700">
             <a:solidFill>
-              <a:srgbClr val="5C9EAD"/>
+              <a:srgbClr val="E7ECEE"/>
             </a:solidFill>
-            <a:prstDash val="dash"/>
+            <a:prstDash val="solid"/>
           </a:ln>
+          <a:effectLst>
+            <a:outerShdw sx="100000" sy="100000" kx="0" ky="0" algn="bl" rotWithShape="0" blurRad="101600" dist="25400" dir="16200000">
+              <a:srgbClr val="294C60">
+                <a:alpha val="4000"/>
+              </a:srgbClr>
+            </a:outerShdw>
+          </a:effectLst>
         </p:spPr>
       </p:sp>
       <p:sp>
@@ -2882,10 +3722,10 @@
         </p:nvSpPr>
         <p:spPr>
           <a:xfrm>
-            <a:off x="1097280" y="2286000"/>
-            <a:ext cx="548640" cy="548640"/>
-          </a:xfrm>
-          <a:prstGeom prst="ellipse">
+            <a:off x="731520" y="1188720"/>
+            <a:ext cx="1828800" cy="73152"/>
+          </a:xfrm>
+          <a:prstGeom prst="rect">
             <a:avLst/>
           </a:prstGeom>
           <a:solidFill>
@@ -2896,14 +3736,41 @@
       </p:sp>
       <p:sp>
         <p:nvSpPr>
-          <p:cNvPr id="6" name="Text 3"/>
-          <p:cNvSpPr/>
-          <p:nvPr/>
-        </p:nvSpPr>
-        <p:spPr>
-          <a:xfrm>
-            <a:off x="1097280" y="2286000"/>
-            <a:ext cx="548640" cy="548640"/>
+          <p:cNvPr id="6" name="Shape 3"/>
+          <p:cNvSpPr/>
+          <p:nvPr/>
+        </p:nvSpPr>
+        <p:spPr>
+          <a:xfrm>
+            <a:off x="914400" y="1463040"/>
+            <a:ext cx="731520" cy="365760"/>
+          </a:xfrm>
+          <a:prstGeom prst="roundRect">
+            <a:avLst>
+              <a:gd name="adj" fmla="val 10000"/>
+            </a:avLst>
+          </a:prstGeom>
+          <a:solidFill>
+            <a:srgbClr val="FAF8EF"/>
+          </a:solidFill>
+          <a:ln w="12700">
+            <a:solidFill>
+              <a:srgbClr val="B8D8E8"/>
+            </a:solidFill>
+            <a:prstDash val="solid"/>
+          </a:ln>
+        </p:spPr>
+      </p:sp>
+      <p:sp>
+        <p:nvSpPr>
+          <p:cNvPr id="7" name="Text 4"/>
+          <p:cNvSpPr/>
+          <p:nvPr/>
+        </p:nvSpPr>
+        <p:spPr>
+          <a:xfrm>
+            <a:off x="914400" y="1463040"/>
+            <a:ext cx="731520" cy="365760"/>
           </a:xfrm>
           <a:prstGeom prst="rect">
             <a:avLst/>
@@ -2919,46 +3786,46 @@
               <a:buNone/>
             </a:pPr>
             <a:r>
-              <a:rPr lang="en-US" sz="1400" b="1" dirty="0">
-                <a:solidFill>
-                  <a:srgbClr val="FAF8EF"/>
+              <a:rPr lang="en-US" sz="1000" b="1" dirty="0">
+                <a:solidFill>
+                  <a:srgbClr val="294C60"/>
                 </a:solidFill>
                 <a:latin typeface="Calibri" pitchFamily="34" charset="0"/>
                 <a:ea typeface="Calibri" pitchFamily="34" charset="-122"/>
                 <a:cs typeface="Calibri" pitchFamily="34" charset="-120"/>
               </a:rPr>
-              <a:t>1</a:t>
-            </a:r>
-            <a:endParaRPr lang="en-US" sz="1400" dirty="0"/>
-          </a:p>
-        </p:txBody>
-      </p:sp>
-      <p:sp>
-        <p:nvSpPr>
-          <p:cNvPr id="7" name="Text 4"/>
-          <p:cNvSpPr/>
-          <p:nvPr/>
-        </p:nvSpPr>
-        <p:spPr>
-          <a:xfrm>
-            <a:off x="548640" y="1463040"/>
-            <a:ext cx="1645920" cy="365760"/>
-          </a:xfrm>
-          <a:prstGeom prst="rect">
-            <a:avLst/>
-          </a:prstGeom>
-          <a:noFill/>
-          <a:ln/>
-        </p:spPr>
-        <p:txBody>
-          <a:bodyPr wrap="square" rtlCol="0" anchor="ctr"/>
-          <a:lstStyle/>
-          <a:p>
-            <a:pPr algn="ctr" indent="0" marL="0">
-              <a:buNone/>
-            </a:pPr>
-            <a:r>
-              <a:rPr lang="en-US" sz="1300" b="1" dirty="0">
+              <a:t>STEP 1</a:t>
+            </a:r>
+            <a:endParaRPr lang="en-US" sz="1000" dirty="0"/>
+          </a:p>
+        </p:txBody>
+      </p:sp>
+      <p:sp>
+        <p:nvSpPr>
+          <p:cNvPr id="8" name="Text 5"/>
+          <p:cNvSpPr/>
+          <p:nvPr/>
+        </p:nvSpPr>
+        <p:spPr>
+          <a:xfrm>
+            <a:off x="914400" y="2011680"/>
+            <a:ext cx="1463040" cy="365760"/>
+          </a:xfrm>
+          <a:prstGeom prst="rect">
+            <a:avLst/>
+          </a:prstGeom>
+          <a:noFill/>
+          <a:ln/>
+        </p:spPr>
+        <p:txBody>
+          <a:bodyPr wrap="square" rtlCol="0" anchor="ctr"/>
+          <a:lstStyle/>
+          <a:p>
+            <a:pPr indent="0" marL="0">
+              <a:buNone/>
+            </a:pPr>
+            <a:r>
+              <a:rPr lang="en-US" sz="1500" b="1" dirty="0">
                 <a:solidFill>
                   <a:srgbClr val="294C60"/>
                 </a:solidFill>
@@ -2968,32 +3835,32 @@
               </a:rPr>
               <a:t>Pre-Screening</a:t>
             </a:r>
-            <a:endParaRPr lang="en-US" sz="1300" dirty="0"/>
-          </a:p>
-        </p:txBody>
-      </p:sp>
-      <p:sp>
-        <p:nvSpPr>
-          <p:cNvPr id="8" name="Text 5"/>
-          <p:cNvSpPr/>
-          <p:nvPr/>
-        </p:nvSpPr>
-        <p:spPr>
-          <a:xfrm>
-            <a:off x="548640" y="3017520"/>
-            <a:ext cx="1645920" cy="1097280"/>
-          </a:xfrm>
-          <a:prstGeom prst="rect">
-            <a:avLst/>
-          </a:prstGeom>
-          <a:noFill/>
-          <a:ln/>
-        </p:spPr>
-        <p:txBody>
-          <a:bodyPr wrap="square" rtlCol="0" anchor="ctr"/>
-          <a:lstStyle/>
-          <a:p>
-            <a:pPr algn="ctr" indent="0" marL="0">
+            <a:endParaRPr lang="en-US" sz="1500" dirty="0"/>
+          </a:p>
+        </p:txBody>
+      </p:sp>
+      <p:sp>
+        <p:nvSpPr>
+          <p:cNvPr id="9" name="Text 6"/>
+          <p:cNvSpPr/>
+          <p:nvPr/>
+        </p:nvSpPr>
+        <p:spPr>
+          <a:xfrm>
+            <a:off x="914400" y="2468880"/>
+            <a:ext cx="1463040" cy="1645920"/>
+          </a:xfrm>
+          <a:prstGeom prst="rect">
+            <a:avLst/>
+          </a:prstGeom>
+          <a:noFill/>
+          <a:ln/>
+        </p:spPr>
+        <p:txBody>
+          <a:bodyPr wrap="square" rtlCol="0" anchor="ctr"/>
+          <a:lstStyle/>
+          <a:p>
+            <a:pPr indent="0" marL="0">
               <a:buNone/>
             </a:pPr>
             <a:r>
@@ -3005,7 +3872,7 @@
                 <a:ea typeface="Calibri" pitchFamily="34" charset="-122"/>
                 <a:cs typeface="Calibri" pitchFamily="34" charset="-120"/>
               </a:rPr>
-              <a:t>Applicant details collected and reviewed.</a:t>
+              <a:t>Applicant details collected, background checks run, and initial suitability reviewed.</a:t>
             </a:r>
             <a:endParaRPr lang="en-US" sz="1100" dirty="0"/>
           </a:p>
@@ -3013,34 +3880,95 @@
       </p:sp>
       <p:sp>
         <p:nvSpPr>
-          <p:cNvPr id="9" name="Shape 6"/>
-          <p:cNvSpPr/>
-          <p:nvPr/>
-        </p:nvSpPr>
-        <p:spPr>
-          <a:xfrm>
-            <a:off x="3108960" y="2286000"/>
-            <a:ext cx="548640" cy="548640"/>
-          </a:xfrm>
-          <a:prstGeom prst="ellipse">
-            <a:avLst/>
-          </a:prstGeom>
-          <a:solidFill>
-            <a:srgbClr val="294C60"/>
-          </a:solidFill>
-          <a:ln/>
-        </p:spPr>
-      </p:sp>
-      <p:sp>
-        <p:nvSpPr>
-          <p:cNvPr id="10" name="Text 7"/>
-          <p:cNvSpPr/>
-          <p:nvPr/>
-        </p:nvSpPr>
-        <p:spPr>
-          <a:xfrm>
-            <a:off x="3108960" y="2286000"/>
-            <a:ext cx="548640" cy="548640"/>
+          <p:cNvPr id="10" name="Shape 7"/>
+          <p:cNvSpPr/>
+          <p:nvPr/>
+        </p:nvSpPr>
+        <p:spPr>
+          <a:xfrm>
+            <a:off x="2743200" y="1188720"/>
+            <a:ext cx="1828800" cy="3291840"/>
+          </a:xfrm>
+          <a:prstGeom prst="roundRect">
+            <a:avLst>
+              <a:gd name="adj" fmla="val 4000"/>
+            </a:avLst>
+          </a:prstGeom>
+          <a:solidFill>
+            <a:srgbClr val="FFFFFF"/>
+          </a:solidFill>
+          <a:ln w="12700">
+            <a:solidFill>
+              <a:srgbClr val="E7ECEE"/>
+            </a:solidFill>
+            <a:prstDash val="solid"/>
+          </a:ln>
+          <a:effectLst>
+            <a:outerShdw sx="100000" sy="100000" kx="0" ky="0" algn="bl" rotWithShape="0" blurRad="101600" dist="25400" dir="16200000">
+              <a:srgbClr val="294C60">
+                <a:alpha val="4000"/>
+              </a:srgbClr>
+            </a:outerShdw>
+          </a:effectLst>
+        </p:spPr>
+      </p:sp>
+      <p:sp>
+        <p:nvSpPr>
+          <p:cNvPr id="11" name="Shape 8"/>
+          <p:cNvSpPr/>
+          <p:nvPr/>
+        </p:nvSpPr>
+        <p:spPr>
+          <a:xfrm>
+            <a:off x="2743200" y="1188720"/>
+            <a:ext cx="1828800" cy="73152"/>
+          </a:xfrm>
+          <a:prstGeom prst="rect">
+            <a:avLst/>
+          </a:prstGeom>
+          <a:solidFill>
+            <a:srgbClr val="5C9EAD"/>
+          </a:solidFill>
+          <a:ln/>
+        </p:spPr>
+      </p:sp>
+      <p:sp>
+        <p:nvSpPr>
+          <p:cNvPr id="12" name="Shape 9"/>
+          <p:cNvSpPr/>
+          <p:nvPr/>
+        </p:nvSpPr>
+        <p:spPr>
+          <a:xfrm>
+            <a:off x="2926080" y="1463040"/>
+            <a:ext cx="731520" cy="365760"/>
+          </a:xfrm>
+          <a:prstGeom prst="roundRect">
+            <a:avLst>
+              <a:gd name="adj" fmla="val 10000"/>
+            </a:avLst>
+          </a:prstGeom>
+          <a:solidFill>
+            <a:srgbClr val="FAF8EF"/>
+          </a:solidFill>
+          <a:ln w="12700">
+            <a:solidFill>
+              <a:srgbClr val="B8D8E8"/>
+            </a:solidFill>
+            <a:prstDash val="solid"/>
+          </a:ln>
+        </p:spPr>
+      </p:sp>
+      <p:sp>
+        <p:nvSpPr>
+          <p:cNvPr id="13" name="Text 10"/>
+          <p:cNvSpPr/>
+          <p:nvPr/>
+        </p:nvSpPr>
+        <p:spPr>
+          <a:xfrm>
+            <a:off x="2926080" y="1463040"/>
+            <a:ext cx="731520" cy="365760"/>
           </a:xfrm>
           <a:prstGeom prst="rect">
             <a:avLst/>
@@ -3056,46 +3984,46 @@
               <a:buNone/>
             </a:pPr>
             <a:r>
-              <a:rPr lang="en-US" sz="1400" b="1" dirty="0">
-                <a:solidFill>
-                  <a:srgbClr val="FAF8EF"/>
+              <a:rPr lang="en-US" sz="1000" b="1" dirty="0">
+                <a:solidFill>
+                  <a:srgbClr val="5C9EAD"/>
                 </a:solidFill>
                 <a:latin typeface="Calibri" pitchFamily="34" charset="0"/>
                 <a:ea typeface="Calibri" pitchFamily="34" charset="-122"/>
                 <a:cs typeface="Calibri" pitchFamily="34" charset="-120"/>
               </a:rPr>
-              <a:t>2</a:t>
-            </a:r>
-            <a:endParaRPr lang="en-US" sz="1400" dirty="0"/>
-          </a:p>
-        </p:txBody>
-      </p:sp>
-      <p:sp>
-        <p:nvSpPr>
-          <p:cNvPr id="11" name="Text 8"/>
-          <p:cNvSpPr/>
-          <p:nvPr/>
-        </p:nvSpPr>
-        <p:spPr>
-          <a:xfrm>
-            <a:off x="2560320" y="1463040"/>
-            <a:ext cx="1645920" cy="365760"/>
-          </a:xfrm>
-          <a:prstGeom prst="rect">
-            <a:avLst/>
-          </a:prstGeom>
-          <a:noFill/>
-          <a:ln/>
-        </p:spPr>
-        <p:txBody>
-          <a:bodyPr wrap="square" rtlCol="0" anchor="ctr"/>
-          <a:lstStyle/>
-          <a:p>
-            <a:pPr algn="ctr" indent="0" marL="0">
-              <a:buNone/>
-            </a:pPr>
-            <a:r>
-              <a:rPr lang="en-US" sz="1300" b="1" dirty="0">
+              <a:t>STEP 2</a:t>
+            </a:r>
+            <a:endParaRPr lang="en-US" sz="1000" dirty="0"/>
+          </a:p>
+        </p:txBody>
+      </p:sp>
+      <p:sp>
+        <p:nvSpPr>
+          <p:cNvPr id="14" name="Text 11"/>
+          <p:cNvSpPr/>
+          <p:nvPr/>
+        </p:nvSpPr>
+        <p:spPr>
+          <a:xfrm>
+            <a:off x="2926080" y="2011680"/>
+            <a:ext cx="1463040" cy="365760"/>
+          </a:xfrm>
+          <a:prstGeom prst="rect">
+            <a:avLst/>
+          </a:prstGeom>
+          <a:noFill/>
+          <a:ln/>
+        </p:spPr>
+        <p:txBody>
+          <a:bodyPr wrap="square" rtlCol="0" anchor="ctr"/>
+          <a:lstStyle/>
+          <a:p>
+            <a:pPr indent="0" marL="0">
+              <a:buNone/>
+            </a:pPr>
+            <a:r>
+              <a:rPr lang="en-US" sz="1500" b="1" dirty="0">
                 <a:solidFill>
                   <a:srgbClr val="294C60"/>
                 </a:solidFill>
@@ -3105,32 +4033,32 @@
               </a:rPr>
               <a:t>Interview</a:t>
             </a:r>
-            <a:endParaRPr lang="en-US" sz="1300" dirty="0"/>
-          </a:p>
-        </p:txBody>
-      </p:sp>
-      <p:sp>
-        <p:nvSpPr>
-          <p:cNvPr id="12" name="Text 9"/>
-          <p:cNvSpPr/>
-          <p:nvPr/>
-        </p:nvSpPr>
-        <p:spPr>
-          <a:xfrm>
-            <a:off x="2560320" y="3017520"/>
-            <a:ext cx="1645920" cy="1097280"/>
-          </a:xfrm>
-          <a:prstGeom prst="rect">
-            <a:avLst/>
-          </a:prstGeom>
-          <a:noFill/>
-          <a:ln/>
-        </p:spPr>
-        <p:txBody>
-          <a:bodyPr wrap="square" rtlCol="0" anchor="ctr"/>
-          <a:lstStyle/>
-          <a:p>
-            <a:pPr algn="ctr" indent="0" marL="0">
+            <a:endParaRPr lang="en-US" sz="1500" dirty="0"/>
+          </a:p>
+        </p:txBody>
+      </p:sp>
+      <p:sp>
+        <p:nvSpPr>
+          <p:cNvPr id="15" name="Text 12"/>
+          <p:cNvSpPr/>
+          <p:nvPr/>
+        </p:nvSpPr>
+        <p:spPr>
+          <a:xfrm>
+            <a:off x="2926080" y="2468880"/>
+            <a:ext cx="1463040" cy="1645920"/>
+          </a:xfrm>
+          <a:prstGeom prst="rect">
+            <a:avLst/>
+          </a:prstGeom>
+          <a:noFill/>
+          <a:ln/>
+        </p:spPr>
+        <p:txBody>
+          <a:bodyPr wrap="square" rtlCol="0" anchor="ctr"/>
+          <a:lstStyle/>
+          <a:p>
+            <a:pPr indent="0" marL="0">
               <a:buNone/>
             </a:pPr>
             <a:r>
@@ -3142,7 +4070,7 @@
                 <a:ea typeface="Calibri" pitchFamily="34" charset="-122"/>
                 <a:cs typeface="Calibri" pitchFamily="34" charset="-120"/>
               </a:rPr>
-              <a:t>Readiness assessment &amp; clinical evaluation.</a:t>
+              <a:t>Face-to-face evaluation process and behavioral readiness evaluations.</a:t>
             </a:r>
             <a:endParaRPr lang="en-US" sz="1100" dirty="0"/>
           </a:p>
@@ -3150,34 +4078,95 @@
       </p:sp>
       <p:sp>
         <p:nvSpPr>
-          <p:cNvPr id="13" name="Shape 10"/>
-          <p:cNvSpPr/>
-          <p:nvPr/>
-        </p:nvSpPr>
-        <p:spPr>
-          <a:xfrm>
-            <a:off x="5120640" y="2286000"/>
-            <a:ext cx="548640" cy="548640"/>
-          </a:xfrm>
-          <a:prstGeom prst="ellipse">
-            <a:avLst/>
-          </a:prstGeom>
-          <a:solidFill>
-            <a:srgbClr val="294C60"/>
-          </a:solidFill>
-          <a:ln/>
-        </p:spPr>
-      </p:sp>
-      <p:sp>
-        <p:nvSpPr>
-          <p:cNvPr id="14" name="Text 11"/>
-          <p:cNvSpPr/>
-          <p:nvPr/>
-        </p:nvSpPr>
-        <p:spPr>
-          <a:xfrm>
-            <a:off x="5120640" y="2286000"/>
-            <a:ext cx="548640" cy="548640"/>
+          <p:cNvPr id="16" name="Shape 13"/>
+          <p:cNvSpPr/>
+          <p:nvPr/>
+        </p:nvSpPr>
+        <p:spPr>
+          <a:xfrm>
+            <a:off x="4754880" y="1188720"/>
+            <a:ext cx="1828800" cy="3291840"/>
+          </a:xfrm>
+          <a:prstGeom prst="roundRect">
+            <a:avLst>
+              <a:gd name="adj" fmla="val 4000"/>
+            </a:avLst>
+          </a:prstGeom>
+          <a:solidFill>
+            <a:srgbClr val="FFFFFF"/>
+          </a:solidFill>
+          <a:ln w="12700">
+            <a:solidFill>
+              <a:srgbClr val="E7ECEE"/>
+            </a:solidFill>
+            <a:prstDash val="solid"/>
+          </a:ln>
+          <a:effectLst>
+            <a:outerShdw sx="100000" sy="100000" kx="0" ky="0" algn="bl" rotWithShape="0" blurRad="101600" dist="25400" dir="16200000">
+              <a:srgbClr val="294C60">
+                <a:alpha val="4000"/>
+              </a:srgbClr>
+            </a:outerShdw>
+          </a:effectLst>
+        </p:spPr>
+      </p:sp>
+      <p:sp>
+        <p:nvSpPr>
+          <p:cNvPr id="17" name="Shape 14"/>
+          <p:cNvSpPr/>
+          <p:nvPr/>
+        </p:nvSpPr>
+        <p:spPr>
+          <a:xfrm>
+            <a:off x="4754880" y="1188720"/>
+            <a:ext cx="1828800" cy="73152"/>
+          </a:xfrm>
+          <a:prstGeom prst="rect">
+            <a:avLst/>
+          </a:prstGeom>
+          <a:solidFill>
+            <a:srgbClr val="C86B4A"/>
+          </a:solidFill>
+          <a:ln/>
+        </p:spPr>
+      </p:sp>
+      <p:sp>
+        <p:nvSpPr>
+          <p:cNvPr id="18" name="Shape 15"/>
+          <p:cNvSpPr/>
+          <p:nvPr/>
+        </p:nvSpPr>
+        <p:spPr>
+          <a:xfrm>
+            <a:off x="4937760" y="1463040"/>
+            <a:ext cx="731520" cy="365760"/>
+          </a:xfrm>
+          <a:prstGeom prst="roundRect">
+            <a:avLst>
+              <a:gd name="adj" fmla="val 10000"/>
+            </a:avLst>
+          </a:prstGeom>
+          <a:solidFill>
+            <a:srgbClr val="FAF8EF"/>
+          </a:solidFill>
+          <a:ln w="12700">
+            <a:solidFill>
+              <a:srgbClr val="B8D8E8"/>
+            </a:solidFill>
+            <a:prstDash val="solid"/>
+          </a:ln>
+        </p:spPr>
+      </p:sp>
+      <p:sp>
+        <p:nvSpPr>
+          <p:cNvPr id="19" name="Text 16"/>
+          <p:cNvSpPr/>
+          <p:nvPr/>
+        </p:nvSpPr>
+        <p:spPr>
+          <a:xfrm>
+            <a:off x="4937760" y="1463040"/>
+            <a:ext cx="731520" cy="365760"/>
           </a:xfrm>
           <a:prstGeom prst="rect">
             <a:avLst/>
@@ -3193,46 +4182,46 @@
               <a:buNone/>
             </a:pPr>
             <a:r>
-              <a:rPr lang="en-US" sz="1400" b="1" dirty="0">
-                <a:solidFill>
-                  <a:srgbClr val="FAF8EF"/>
+              <a:rPr lang="en-US" sz="1000" b="1" dirty="0">
+                <a:solidFill>
+                  <a:srgbClr val="C86B4A"/>
                 </a:solidFill>
                 <a:latin typeface="Calibri" pitchFamily="34" charset="0"/>
                 <a:ea typeface="Calibri" pitchFamily="34" charset="-122"/>
                 <a:cs typeface="Calibri" pitchFamily="34" charset="-120"/>
               </a:rPr>
-              <a:t>3</a:t>
-            </a:r>
-            <a:endParaRPr lang="en-US" sz="1400" dirty="0"/>
-          </a:p>
-        </p:txBody>
-      </p:sp>
-      <p:sp>
-        <p:nvSpPr>
-          <p:cNvPr id="15" name="Text 12"/>
-          <p:cNvSpPr/>
-          <p:nvPr/>
-        </p:nvSpPr>
-        <p:spPr>
-          <a:xfrm>
-            <a:off x="4572000" y="1463040"/>
-            <a:ext cx="1645920" cy="365760"/>
-          </a:xfrm>
-          <a:prstGeom prst="rect">
-            <a:avLst/>
-          </a:prstGeom>
-          <a:noFill/>
-          <a:ln/>
-        </p:spPr>
-        <p:txBody>
-          <a:bodyPr wrap="square" rtlCol="0" anchor="ctr"/>
-          <a:lstStyle/>
-          <a:p>
-            <a:pPr algn="ctr" indent="0" marL="0">
-              <a:buNone/>
-            </a:pPr>
-            <a:r>
-              <a:rPr lang="en-US" sz="1300" b="1" dirty="0">
+              <a:t>STEP 3</a:t>
+            </a:r>
+            <a:endParaRPr lang="en-US" sz="1000" dirty="0"/>
+          </a:p>
+        </p:txBody>
+      </p:sp>
+      <p:sp>
+        <p:nvSpPr>
+          <p:cNvPr id="20" name="Text 17"/>
+          <p:cNvSpPr/>
+          <p:nvPr/>
+        </p:nvSpPr>
+        <p:spPr>
+          <a:xfrm>
+            <a:off x="4937760" y="2011680"/>
+            <a:ext cx="1463040" cy="365760"/>
+          </a:xfrm>
+          <a:prstGeom prst="rect">
+            <a:avLst/>
+          </a:prstGeom>
+          <a:noFill/>
+          <a:ln/>
+        </p:spPr>
+        <p:txBody>
+          <a:bodyPr wrap="square" rtlCol="0" anchor="ctr"/>
+          <a:lstStyle/>
+          <a:p>
+            <a:pPr indent="0" marL="0">
+              <a:buNone/>
+            </a:pPr>
+            <a:r>
+              <a:rPr lang="en-US" sz="1500" b="1" dirty="0">
                 <a:solidFill>
                   <a:srgbClr val="294C60"/>
                 </a:solidFill>
@@ -3242,32 +4231,32 @@
               </a:rPr>
               <a:t>Decision</a:t>
             </a:r>
-            <a:endParaRPr lang="en-US" sz="1300" dirty="0"/>
-          </a:p>
-        </p:txBody>
-      </p:sp>
-      <p:sp>
-        <p:nvSpPr>
-          <p:cNvPr id="16" name="Text 13"/>
-          <p:cNvSpPr/>
-          <p:nvPr/>
-        </p:nvSpPr>
-        <p:spPr>
-          <a:xfrm>
-            <a:off x="4572000" y="3017520"/>
-            <a:ext cx="1645920" cy="1097280"/>
-          </a:xfrm>
-          <a:prstGeom prst="rect">
-            <a:avLst/>
-          </a:prstGeom>
-          <a:noFill/>
-          <a:ln/>
-        </p:spPr>
-        <p:txBody>
-          <a:bodyPr wrap="square" rtlCol="0" anchor="ctr"/>
-          <a:lstStyle/>
-          <a:p>
-            <a:pPr algn="ctr" indent="0" marL="0">
+            <a:endParaRPr lang="en-US" sz="1500" dirty="0"/>
+          </a:p>
+        </p:txBody>
+      </p:sp>
+      <p:sp>
+        <p:nvSpPr>
+          <p:cNvPr id="21" name="Text 18"/>
+          <p:cNvSpPr/>
+          <p:nvPr/>
+        </p:nvSpPr>
+        <p:spPr>
+          <a:xfrm>
+            <a:off x="4937760" y="2468880"/>
+            <a:ext cx="1463040" cy="1645920"/>
+          </a:xfrm>
+          <a:prstGeom prst="rect">
+            <a:avLst/>
+          </a:prstGeom>
+          <a:noFill/>
+          <a:ln/>
+        </p:spPr>
+        <p:txBody>
+          <a:bodyPr wrap="square" rtlCol="0" anchor="ctr"/>
+          <a:lstStyle/>
+          <a:p>
+            <a:pPr indent="0" marL="0">
               <a:buNone/>
             </a:pPr>
             <a:r>
@@ -3279,7 +4268,7 @@
                 <a:ea typeface="Calibri" pitchFamily="34" charset="-122"/>
                 <a:cs typeface="Calibri" pitchFamily="34" charset="-120"/>
               </a:rPr>
-              <a:t>Committee review and official approval.</a:t>
+              <a:t>Committee gathers to audit files, vote, and document approvals or conditional next steps.</a:t>
             </a:r>
             <a:endParaRPr lang="en-US" sz="1100" dirty="0"/>
           </a:p>
@@ -3287,16 +4276,50 @@
       </p:sp>
       <p:sp>
         <p:nvSpPr>
-          <p:cNvPr id="17" name="Shape 14"/>
-          <p:cNvSpPr/>
-          <p:nvPr/>
-        </p:nvSpPr>
-        <p:spPr>
-          <a:xfrm>
-            <a:off x="7132320" y="2286000"/>
-            <a:ext cx="548640" cy="548640"/>
-          </a:xfrm>
-          <a:prstGeom prst="ellipse">
+          <p:cNvPr id="22" name="Shape 19"/>
+          <p:cNvSpPr/>
+          <p:nvPr/>
+        </p:nvSpPr>
+        <p:spPr>
+          <a:xfrm>
+            <a:off x="6766560" y="1188720"/>
+            <a:ext cx="1828800" cy="3291840"/>
+          </a:xfrm>
+          <a:prstGeom prst="roundRect">
+            <a:avLst>
+              <a:gd name="adj" fmla="val 4000"/>
+            </a:avLst>
+          </a:prstGeom>
+          <a:solidFill>
+            <a:srgbClr val="FFFFFF"/>
+          </a:solidFill>
+          <a:ln w="12700">
+            <a:solidFill>
+              <a:srgbClr val="E7ECEE"/>
+            </a:solidFill>
+            <a:prstDash val="solid"/>
+          </a:ln>
+          <a:effectLst>
+            <a:outerShdw sx="100000" sy="100000" kx="0" ky="0" algn="bl" rotWithShape="0" blurRad="101600" dist="25400" dir="16200000">
+              <a:srgbClr val="294C60">
+                <a:alpha val="4000"/>
+              </a:srgbClr>
+            </a:outerShdw>
+          </a:effectLst>
+        </p:spPr>
+      </p:sp>
+      <p:sp>
+        <p:nvSpPr>
+          <p:cNvPr id="23" name="Shape 20"/>
+          <p:cNvSpPr/>
+          <p:nvPr/>
+        </p:nvSpPr>
+        <p:spPr>
+          <a:xfrm>
+            <a:off x="6766560" y="1188720"/>
+            <a:ext cx="1828800" cy="73152"/>
+          </a:xfrm>
+          <a:prstGeom prst="rect">
             <a:avLst/>
           </a:prstGeom>
           <a:solidFill>
@@ -3307,14 +4330,41 @@
       </p:sp>
       <p:sp>
         <p:nvSpPr>
-          <p:cNvPr id="18" name="Text 15"/>
-          <p:cNvSpPr/>
-          <p:nvPr/>
-        </p:nvSpPr>
-        <p:spPr>
-          <a:xfrm>
-            <a:off x="7132320" y="2286000"/>
-            <a:ext cx="548640" cy="548640"/>
+          <p:cNvPr id="24" name="Shape 21"/>
+          <p:cNvSpPr/>
+          <p:nvPr/>
+        </p:nvSpPr>
+        <p:spPr>
+          <a:xfrm>
+            <a:off x="6949440" y="1463040"/>
+            <a:ext cx="731520" cy="365760"/>
+          </a:xfrm>
+          <a:prstGeom prst="roundRect">
+            <a:avLst>
+              <a:gd name="adj" fmla="val 10000"/>
+            </a:avLst>
+          </a:prstGeom>
+          <a:solidFill>
+            <a:srgbClr val="FAF8EF"/>
+          </a:solidFill>
+          <a:ln w="12700">
+            <a:solidFill>
+              <a:srgbClr val="B8D8E8"/>
+            </a:solidFill>
+            <a:prstDash val="solid"/>
+          </a:ln>
+        </p:spPr>
+      </p:sp>
+      <p:sp>
+        <p:nvSpPr>
+          <p:cNvPr id="25" name="Text 22"/>
+          <p:cNvSpPr/>
+          <p:nvPr/>
+        </p:nvSpPr>
+        <p:spPr>
+          <a:xfrm>
+            <a:off x="6949440" y="1463040"/>
+            <a:ext cx="731520" cy="365760"/>
           </a:xfrm>
           <a:prstGeom prst="rect">
             <a:avLst/>
@@ -3330,46 +4380,46 @@
               <a:buNone/>
             </a:pPr>
             <a:r>
-              <a:rPr lang="en-US" sz="1400" b="1" dirty="0">
-                <a:solidFill>
-                  <a:srgbClr val="FAF8EF"/>
+              <a:rPr lang="en-US" sz="1000" b="1" dirty="0">
+                <a:solidFill>
+                  <a:srgbClr val="294C60"/>
                 </a:solidFill>
                 <a:latin typeface="Calibri" pitchFamily="34" charset="0"/>
                 <a:ea typeface="Calibri" pitchFamily="34" charset="-122"/>
                 <a:cs typeface="Calibri" pitchFamily="34" charset="-120"/>
               </a:rPr>
-              <a:t>4</a:t>
-            </a:r>
-            <a:endParaRPr lang="en-US" sz="1400" dirty="0"/>
-          </a:p>
-        </p:txBody>
-      </p:sp>
-      <p:sp>
-        <p:nvSpPr>
-          <p:cNvPr id="19" name="Text 16"/>
-          <p:cNvSpPr/>
-          <p:nvPr/>
-        </p:nvSpPr>
-        <p:spPr>
-          <a:xfrm>
-            <a:off x="6583680" y="1463040"/>
-            <a:ext cx="1645920" cy="365760"/>
-          </a:xfrm>
-          <a:prstGeom prst="rect">
-            <a:avLst/>
-          </a:prstGeom>
-          <a:noFill/>
-          <a:ln/>
-        </p:spPr>
-        <p:txBody>
-          <a:bodyPr wrap="square" rtlCol="0" anchor="ctr"/>
-          <a:lstStyle/>
-          <a:p>
-            <a:pPr algn="ctr" indent="0" marL="0">
-              <a:buNone/>
-            </a:pPr>
-            <a:r>
-              <a:rPr lang="en-US" sz="1300" b="1" dirty="0">
+              <a:t>STEP 4</a:t>
+            </a:r>
+            <a:endParaRPr lang="en-US" sz="1000" dirty="0"/>
+          </a:p>
+        </p:txBody>
+      </p:sp>
+      <p:sp>
+        <p:nvSpPr>
+          <p:cNvPr id="26" name="Text 23"/>
+          <p:cNvSpPr/>
+          <p:nvPr/>
+        </p:nvSpPr>
+        <p:spPr>
+          <a:xfrm>
+            <a:off x="6949440" y="2011680"/>
+            <a:ext cx="1463040" cy="365760"/>
+          </a:xfrm>
+          <a:prstGeom prst="rect">
+            <a:avLst/>
+          </a:prstGeom>
+          <a:noFill/>
+          <a:ln/>
+        </p:spPr>
+        <p:txBody>
+          <a:bodyPr wrap="square" rtlCol="0" anchor="ctr"/>
+          <a:lstStyle/>
+          <a:p>
+            <a:pPr indent="0" marL="0">
+              <a:buNone/>
+            </a:pPr>
+            <a:r>
+              <a:rPr lang="en-US" sz="1500" b="1" dirty="0">
                 <a:solidFill>
                   <a:srgbClr val="294C60"/>
                 </a:solidFill>
@@ -3379,32 +4429,32 @@
               </a:rPr>
               <a:t>Welcome Day</a:t>
             </a:r>
-            <a:endParaRPr lang="en-US" sz="1300" dirty="0"/>
-          </a:p>
-        </p:txBody>
-      </p:sp>
-      <p:sp>
-        <p:nvSpPr>
-          <p:cNvPr id="20" name="Text 17"/>
-          <p:cNvSpPr/>
-          <p:nvPr/>
-        </p:nvSpPr>
-        <p:spPr>
-          <a:xfrm>
-            <a:off x="6583680" y="3017520"/>
-            <a:ext cx="1645920" cy="1097280"/>
-          </a:xfrm>
-          <a:prstGeom prst="rect">
-            <a:avLst/>
-          </a:prstGeom>
-          <a:noFill/>
-          <a:ln/>
-        </p:spPr>
-        <p:txBody>
-          <a:bodyPr wrap="square" rtlCol="0" anchor="ctr"/>
-          <a:lstStyle/>
-          <a:p>
-            <a:pPr algn="ctr" indent="0" marL="0">
+            <a:endParaRPr lang="en-US" sz="1500" dirty="0"/>
+          </a:p>
+        </p:txBody>
+      </p:sp>
+      <p:sp>
+        <p:nvSpPr>
+          <p:cNvPr id="27" name="Text 24"/>
+          <p:cNvSpPr/>
+          <p:nvPr/>
+        </p:nvSpPr>
+        <p:spPr>
+          <a:xfrm>
+            <a:off x="6949440" y="2468880"/>
+            <a:ext cx="1463040" cy="1645920"/>
+          </a:xfrm>
+          <a:prstGeom prst="rect">
+            <a:avLst/>
+          </a:prstGeom>
+          <a:noFill/>
+          <a:ln/>
+        </p:spPr>
+        <p:txBody>
+          <a:bodyPr wrap="square" rtlCol="0" anchor="ctr"/>
+          <a:lstStyle/>
+          <a:p>
+            <a:pPr indent="0" marL="0">
               <a:buNone/>
             </a:pPr>
             <a:r>
@@ -3416,7 +4466,7 @@
                 <a:ea typeface="Calibri" pitchFamily="34" charset="-122"/>
                 <a:cs typeface="Calibri" pitchFamily="34" charset="-120"/>
               </a:rPr>
-              <a:t>Bedroom assignment and official intake.</a:t>
+              <a:t>Bedroom set up, access code provided, resident covenant signed, and orientation complete.</a:t>
             </a:r>
             <a:endParaRPr lang="en-US" sz="1100" dirty="0"/>
           </a:p>
@@ -3470,7 +4520,7 @@
         </p:blipFill>
         <p:spPr>
           <a:xfrm>
-            <a:off x="7772400" y="365760"/>
+            <a:off x="7772400" y="274320"/>
             <a:ext cx="1005840" cy="274320"/>
           </a:xfrm>
           <a:prstGeom prst="rect">
@@ -3526,50 +4576,116 @@
         <p:spPr>
           <a:xfrm>
             <a:off x="731520" y="1188720"/>
-            <a:ext cx="2377440" cy="3108960"/>
+            <a:ext cx="4572000" cy="3291840"/>
           </a:xfrm>
           <a:prstGeom prst="roundRect">
             <a:avLst>
-              <a:gd name="adj" fmla="val 3077"/>
+              <a:gd name="adj" fmla="val 2222"/>
             </a:avLst>
           </a:prstGeom>
           <a:solidFill>
-            <a:srgbClr val="E7ECEE"/>
+            <a:srgbClr val="FFFFFF"/>
           </a:solidFill>
           <a:ln w="12700">
             <a:solidFill>
-              <a:srgbClr val="B8D8E8"/>
+              <a:srgbClr val="E7ECEE"/>
             </a:solidFill>
             <a:prstDash val="solid"/>
           </a:ln>
-        </p:spPr>
-      </p:sp>
-      <p:sp>
-        <p:nvSpPr>
-          <p:cNvPr id="5" name="Text 2"/>
-          <p:cNvSpPr/>
-          <p:nvPr/>
-        </p:nvSpPr>
-        <p:spPr>
-          <a:xfrm>
-            <a:off x="731520" y="1463040"/>
-            <a:ext cx="2377440" cy="822960"/>
-          </a:xfrm>
-          <a:prstGeom prst="rect">
-            <a:avLst/>
-          </a:prstGeom>
-          <a:noFill/>
-          <a:ln/>
-        </p:spPr>
-        <p:txBody>
-          <a:bodyPr wrap="square" rtlCol="0" anchor="ctr"/>
-          <a:lstStyle/>
-          <a:p>
-            <a:pPr algn="ctr" indent="0" marL="0">
-              <a:buNone/>
-            </a:pPr>
-            <a:r>
-              <a:rPr lang="en-US" sz="5400" b="1" dirty="0">
+          <a:effectLst>
+            <a:outerShdw sx="100000" sy="100000" kx="0" ky="0" algn="bl" rotWithShape="0" blurRad="101600" dist="25400" dir="16200000">
+              <a:srgbClr val="294C60">
+                <a:alpha val="4000"/>
+              </a:srgbClr>
+            </a:outerShdw>
+          </a:effectLst>
+        </p:spPr>
+      </p:sp>
+      <p:sp>
+        <p:nvSpPr>
+          <p:cNvPr id="5" name="Shape 2"/>
+          <p:cNvSpPr/>
+          <p:nvPr/>
+        </p:nvSpPr>
+        <p:spPr>
+          <a:xfrm>
+            <a:off x="731520" y="1188720"/>
+            <a:ext cx="4572000" cy="73152"/>
+          </a:xfrm>
+          <a:prstGeom prst="rect">
+            <a:avLst/>
+          </a:prstGeom>
+          <a:solidFill>
+            <a:srgbClr val="294C60"/>
+          </a:solidFill>
+          <a:ln/>
+        </p:spPr>
+      </p:sp>
+      <p:sp>
+        <p:nvSpPr>
+          <p:cNvPr id="6" name="Text 3"/>
+          <p:cNvSpPr/>
+          <p:nvPr/>
+        </p:nvSpPr>
+        <p:spPr>
+          <a:xfrm>
+            <a:off x="1097280" y="1463040"/>
+            <a:ext cx="3840480" cy="365760"/>
+          </a:xfrm>
+          <a:prstGeom prst="rect">
+            <a:avLst/>
+          </a:prstGeom>
+          <a:noFill/>
+          <a:ln/>
+        </p:spPr>
+        <p:txBody>
+          <a:bodyPr wrap="square" rtlCol="0" anchor="ctr"/>
+          <a:lstStyle/>
+          <a:p>
+            <a:pPr indent="0" marL="0">
+              <a:buNone/>
+            </a:pPr>
+            <a:r>
+              <a:rPr lang="en-US" sz="1100" b="1" spc="200" kern="0" dirty="0">
+                <a:solidFill>
+                  <a:srgbClr val="5E7890"/>
+                </a:solidFill>
+                <a:latin typeface="Calibri" pitchFamily="34" charset="0"/>
+                <a:ea typeface="Calibri" pitchFamily="34" charset="-122"/>
+                <a:cs typeface="Calibri" pitchFamily="34" charset="-120"/>
+              </a:rPr>
+              <a:t>HOUSING STABILITY RATE</a:t>
+            </a:r>
+            <a:endParaRPr lang="en-US" sz="1100" dirty="0"/>
+          </a:p>
+        </p:txBody>
+      </p:sp>
+      <p:sp>
+        <p:nvSpPr>
+          <p:cNvPr id="7" name="Text 4"/>
+          <p:cNvSpPr/>
+          <p:nvPr/>
+        </p:nvSpPr>
+        <p:spPr>
+          <a:xfrm>
+            <a:off x="1097280" y="1828800"/>
+            <a:ext cx="2194560" cy="1097280"/>
+          </a:xfrm>
+          <a:prstGeom prst="rect">
+            <a:avLst/>
+          </a:prstGeom>
+          <a:noFill/>
+          <a:ln/>
+        </p:spPr>
+        <p:txBody>
+          <a:bodyPr wrap="square" rtlCol="0" anchor="ctr"/>
+          <a:lstStyle/>
+          <a:p>
+            <a:pPr indent="0" marL="0">
+              <a:buNone/>
+            </a:pPr>
+            <a:r>
+              <a:rPr lang="en-US" sz="7200" b="1" dirty="0">
                 <a:solidFill>
                   <a:srgbClr val="294C60"/>
                 </a:solidFill>
@@ -3579,32 +4695,32 @@
               </a:rPr>
               <a:t>85%</a:t>
             </a:r>
-            <a:endParaRPr lang="en-US" sz="5400" dirty="0"/>
-          </a:p>
-        </p:txBody>
-      </p:sp>
-      <p:sp>
-        <p:nvSpPr>
-          <p:cNvPr id="6" name="Text 3"/>
-          <p:cNvSpPr/>
-          <p:nvPr/>
-        </p:nvSpPr>
-        <p:spPr>
-          <a:xfrm>
-            <a:off x="731520" y="2468880"/>
-            <a:ext cx="2377440" cy="365760"/>
-          </a:xfrm>
-          <a:prstGeom prst="rect">
-            <a:avLst/>
-          </a:prstGeom>
-          <a:noFill/>
-          <a:ln/>
-        </p:spPr>
-        <p:txBody>
-          <a:bodyPr wrap="square" rtlCol="0" anchor="ctr"/>
-          <a:lstStyle/>
-          <a:p>
-            <a:pPr algn="ctr" indent="0" marL="0">
+            <a:endParaRPr lang="en-US" sz="7200" dirty="0"/>
+          </a:p>
+        </p:txBody>
+      </p:sp>
+      <p:sp>
+        <p:nvSpPr>
+          <p:cNvPr id="8" name="Text 5"/>
+          <p:cNvSpPr/>
+          <p:nvPr/>
+        </p:nvSpPr>
+        <p:spPr>
+          <a:xfrm>
+            <a:off x="2926080" y="2011680"/>
+            <a:ext cx="2194560" cy="365760"/>
+          </a:xfrm>
+          <a:prstGeom prst="rect">
+            <a:avLst/>
+          </a:prstGeom>
+          <a:noFill/>
+          <a:ln/>
+        </p:spPr>
+        <p:txBody>
+          <a:bodyPr wrap="square" rtlCol="0" anchor="ctr"/>
+          <a:lstStyle/>
+          <a:p>
+            <a:pPr indent="0" marL="0">
               <a:buNone/>
             </a:pPr>
             <a:r>
@@ -3624,26 +4740,26 @@
       </p:sp>
       <p:sp>
         <p:nvSpPr>
-          <p:cNvPr id="7" name="Text 4"/>
-          <p:cNvSpPr/>
-          <p:nvPr/>
-        </p:nvSpPr>
-        <p:spPr>
-          <a:xfrm>
-            <a:off x="822960" y="2926080"/>
-            <a:ext cx="2194560" cy="914400"/>
-          </a:xfrm>
-          <a:prstGeom prst="rect">
-            <a:avLst/>
-          </a:prstGeom>
-          <a:noFill/>
-          <a:ln/>
-        </p:spPr>
-        <p:txBody>
-          <a:bodyPr wrap="square" rtlCol="0" anchor="ctr"/>
-          <a:lstStyle/>
-          <a:p>
-            <a:pPr algn="ctr" indent="0" marL="0">
+          <p:cNvPr id="9" name="Text 6"/>
+          <p:cNvSpPr/>
+          <p:nvPr/>
+        </p:nvSpPr>
+        <p:spPr>
+          <a:xfrm>
+            <a:off x="2926080" y="2377440"/>
+            <a:ext cx="2194560" cy="640080"/>
+          </a:xfrm>
+          <a:prstGeom prst="rect">
+            <a:avLst/>
+          </a:prstGeom>
+          <a:noFill/>
+          <a:ln/>
+        </p:spPr>
+        <p:txBody>
+          <a:bodyPr wrap="square" rtlCol="0" anchor="ctr"/>
+          <a:lstStyle/>
+          <a:p>
+            <a:pPr indent="0" marL="0">
               <a:buNone/>
             </a:pPr>
             <a:r>
@@ -3655,7 +4771,7 @@
                 <a:ea typeface="Calibri" pitchFamily="34" charset="-122"/>
                 <a:cs typeface="Calibri" pitchFamily="34" charset="-120"/>
               </a:rPr>
-              <a:t>Graduates maintaining permanent housing for 12+ months.</a:t>
+              <a:t>Graduates maintaining permanent housing for 12+ months post-transition.</a:t>
             </a:r>
             <a:endParaRPr lang="en-US" sz="1100" dirty="0"/>
           </a:p>
@@ -3663,59 +4779,169 @@
       </p:sp>
       <p:sp>
         <p:nvSpPr>
-          <p:cNvPr id="8" name="Shape 5"/>
-          <p:cNvSpPr/>
-          <p:nvPr/>
-        </p:nvSpPr>
-        <p:spPr>
-          <a:xfrm>
-            <a:off x="3383280" y="1188720"/>
-            <a:ext cx="2377440" cy="3108960"/>
+          <p:cNvPr id="10" name="Shape 7"/>
+          <p:cNvSpPr/>
+          <p:nvPr/>
+        </p:nvSpPr>
+        <p:spPr>
+          <a:xfrm>
+            <a:off x="1097280" y="3474720"/>
+            <a:ext cx="3840480" cy="274320"/>
           </a:xfrm>
           <a:prstGeom prst="roundRect">
             <a:avLst>
-              <a:gd name="adj" fmla="val 3077"/>
+              <a:gd name="adj" fmla="val 50000"/>
             </a:avLst>
           </a:prstGeom>
           <a:solidFill>
             <a:srgbClr val="E7ECEE"/>
+          </a:solidFill>
+          <a:ln/>
+        </p:spPr>
+      </p:sp>
+      <p:sp>
+        <p:nvSpPr>
+          <p:cNvPr id="11" name="Shape 8"/>
+          <p:cNvSpPr/>
+          <p:nvPr/>
+        </p:nvSpPr>
+        <p:spPr>
+          <a:xfrm>
+            <a:off x="1097280" y="3474720"/>
+            <a:ext cx="3264408" cy="274320"/>
+          </a:xfrm>
+          <a:prstGeom prst="roundRect">
+            <a:avLst>
+              <a:gd name="adj" fmla="val 50000"/>
+            </a:avLst>
+          </a:prstGeom>
+          <a:solidFill>
+            <a:srgbClr val="C86B4A"/>
+          </a:solidFill>
+          <a:ln/>
+        </p:spPr>
+      </p:sp>
+      <p:sp>
+        <p:nvSpPr>
+          <p:cNvPr id="12" name="Text 9"/>
+          <p:cNvSpPr/>
+          <p:nvPr/>
+        </p:nvSpPr>
+        <p:spPr>
+          <a:xfrm>
+            <a:off x="1097280" y="3840480"/>
+            <a:ext cx="3840480" cy="274320"/>
+          </a:xfrm>
+          <a:prstGeom prst="rect">
+            <a:avLst/>
+          </a:prstGeom>
+          <a:noFill/>
+          <a:ln/>
+        </p:spPr>
+        <p:txBody>
+          <a:bodyPr wrap="square" rtlCol="0" anchor="ctr"/>
+          <a:lstStyle/>
+          <a:p>
+            <a:pPr indent="0" marL="0">
+              <a:buNone/>
+            </a:pPr>
+            <a:r>
+              <a:rPr lang="en-US" sz="1000" i="1" dirty="0">
+                <a:solidFill>
+                  <a:srgbClr val="5E7890"/>
+                </a:solidFill>
+                <a:latin typeface="Calibri" pitchFamily="34" charset="0"/>
+                <a:ea typeface="Calibri" pitchFamily="34" charset="-122"/>
+                <a:cs typeface="Calibri" pitchFamily="34" charset="-120"/>
+              </a:rPr>
+              <a:t>Current Program Goal: 80%</a:t>
+            </a:r>
+            <a:endParaRPr lang="en-US" sz="1000" dirty="0"/>
+          </a:p>
+        </p:txBody>
+      </p:sp>
+      <p:sp>
+        <p:nvSpPr>
+          <p:cNvPr id="13" name="Shape 10"/>
+          <p:cNvSpPr/>
+          <p:nvPr/>
+        </p:nvSpPr>
+        <p:spPr>
+          <a:xfrm>
+            <a:off x="5486400" y="1188720"/>
+            <a:ext cx="2926080" cy="1554480"/>
+          </a:xfrm>
+          <a:prstGeom prst="roundRect">
+            <a:avLst>
+              <a:gd name="adj" fmla="val 4706"/>
+            </a:avLst>
+          </a:prstGeom>
+          <a:solidFill>
+            <a:srgbClr val="FFFFFF"/>
           </a:solidFill>
           <a:ln w="12700">
             <a:solidFill>
-              <a:srgbClr val="B8D8E8"/>
+              <a:srgbClr val="E7ECEE"/>
             </a:solidFill>
             <a:prstDash val="solid"/>
           </a:ln>
-        </p:spPr>
-      </p:sp>
-      <p:sp>
-        <p:nvSpPr>
-          <p:cNvPr id="9" name="Text 6"/>
-          <p:cNvSpPr/>
-          <p:nvPr/>
-        </p:nvSpPr>
-        <p:spPr>
-          <a:xfrm>
-            <a:off x="3383280" y="1463040"/>
-            <a:ext cx="2377440" cy="822960"/>
-          </a:xfrm>
-          <a:prstGeom prst="rect">
-            <a:avLst/>
-          </a:prstGeom>
-          <a:noFill/>
-          <a:ln/>
-        </p:spPr>
-        <p:txBody>
-          <a:bodyPr wrap="square" rtlCol="0" anchor="ctr"/>
-          <a:lstStyle/>
-          <a:p>
-            <a:pPr algn="ctr" indent="0" marL="0">
-              <a:buNone/>
-            </a:pPr>
-            <a:r>
-              <a:rPr lang="en-US" sz="5400" b="1" dirty="0">
-                <a:solidFill>
-                  <a:srgbClr val="C86B4A"/>
+          <a:effectLst>
+            <a:outerShdw sx="100000" sy="100000" kx="0" ky="0" algn="bl" rotWithShape="0" blurRad="101600" dist="25400" dir="16200000">
+              <a:srgbClr val="294C60">
+                <a:alpha val="4000"/>
+              </a:srgbClr>
+            </a:outerShdw>
+          </a:effectLst>
+        </p:spPr>
+      </p:sp>
+      <p:sp>
+        <p:nvSpPr>
+          <p:cNvPr id="14" name="Shape 11"/>
+          <p:cNvSpPr/>
+          <p:nvPr/>
+        </p:nvSpPr>
+        <p:spPr>
+          <a:xfrm>
+            <a:off x="5486400" y="1188720"/>
+            <a:ext cx="73152" cy="1554480"/>
+          </a:xfrm>
+          <a:prstGeom prst="rect">
+            <a:avLst/>
+          </a:prstGeom>
+          <a:solidFill>
+            <a:srgbClr val="5C9EAD"/>
+          </a:solidFill>
+          <a:ln/>
+        </p:spPr>
+      </p:sp>
+      <p:sp>
+        <p:nvSpPr>
+          <p:cNvPr id="15" name="Text 12"/>
+          <p:cNvSpPr/>
+          <p:nvPr/>
+        </p:nvSpPr>
+        <p:spPr>
+          <a:xfrm>
+            <a:off x="5760720" y="1280160"/>
+            <a:ext cx="2468880" cy="640080"/>
+          </a:xfrm>
+          <a:prstGeom prst="rect">
+            <a:avLst/>
+          </a:prstGeom>
+          <a:noFill/>
+          <a:ln/>
+        </p:spPr>
+        <p:txBody>
+          <a:bodyPr wrap="square" rtlCol="0" anchor="ctr"/>
+          <a:lstStyle/>
+          <a:p>
+            <a:pPr indent="0" marL="0">
+              <a:buNone/>
+            </a:pPr>
+            <a:r>
+              <a:rPr lang="en-US" sz="3600" b="1" dirty="0">
+                <a:solidFill>
+                  <a:srgbClr val="5C9EAD"/>
                 </a:solidFill>
                 <a:latin typeface="Georgia" pitchFamily="34" charset="0"/>
                 <a:ea typeface="Georgia" pitchFamily="34" charset="-122"/>
@@ -3723,36 +4949,36 @@
               </a:rPr>
               <a:t>120+</a:t>
             </a:r>
-            <a:endParaRPr lang="en-US" sz="5400" dirty="0"/>
-          </a:p>
-        </p:txBody>
-      </p:sp>
-      <p:sp>
-        <p:nvSpPr>
-          <p:cNvPr id="10" name="Text 7"/>
-          <p:cNvSpPr/>
-          <p:nvPr/>
-        </p:nvSpPr>
-        <p:spPr>
-          <a:xfrm>
-            <a:off x="3383280" y="2468880"/>
-            <a:ext cx="2377440" cy="365760"/>
-          </a:xfrm>
-          <a:prstGeom prst="rect">
-            <a:avLst/>
-          </a:prstGeom>
-          <a:noFill/>
-          <a:ln/>
-        </p:spPr>
-        <p:txBody>
-          <a:bodyPr wrap="square" rtlCol="0" anchor="ctr"/>
-          <a:lstStyle/>
-          <a:p>
-            <a:pPr algn="ctr" indent="0" marL="0">
-              <a:buNone/>
-            </a:pPr>
-            <a:r>
-              <a:rPr lang="en-US" sz="1400" b="1" dirty="0">
+            <a:endParaRPr lang="en-US" sz="3600" dirty="0"/>
+          </a:p>
+        </p:txBody>
+      </p:sp>
+      <p:sp>
+        <p:nvSpPr>
+          <p:cNvPr id="16" name="Text 13"/>
+          <p:cNvSpPr/>
+          <p:nvPr/>
+        </p:nvSpPr>
+        <p:spPr>
+          <a:xfrm>
+            <a:off x="5760720" y="1920240"/>
+            <a:ext cx="2468880" cy="274320"/>
+          </a:xfrm>
+          <a:prstGeom prst="rect">
+            <a:avLst/>
+          </a:prstGeom>
+          <a:noFill/>
+          <a:ln/>
+        </p:spPr>
+        <p:txBody>
+          <a:bodyPr wrap="square" rtlCol="0" anchor="ctr"/>
+          <a:lstStyle/>
+          <a:p>
+            <a:pPr indent="0" marL="0">
+              <a:buNone/>
+            </a:pPr>
+            <a:r>
+              <a:rPr lang="en-US" sz="1200" b="1" dirty="0">
                 <a:solidFill>
                   <a:srgbClr val="27343B"/>
                 </a:solidFill>
@@ -3760,106 +4986,133 @@
                 <a:ea typeface="Calibri" pitchFamily="34" charset="-122"/>
                 <a:cs typeface="Calibri" pitchFamily="34" charset="-120"/>
               </a:rPr>
-              <a:t>Residents Reinstated</a:t>
-            </a:r>
-            <a:endParaRPr lang="en-US" sz="1400" dirty="0"/>
-          </a:p>
-        </p:txBody>
-      </p:sp>
-      <p:sp>
-        <p:nvSpPr>
-          <p:cNvPr id="11" name="Text 8"/>
-          <p:cNvSpPr/>
-          <p:nvPr/>
-        </p:nvSpPr>
-        <p:spPr>
-          <a:xfrm>
-            <a:off x="3474720" y="2926080"/>
-            <a:ext cx="2194560" cy="914400"/>
-          </a:xfrm>
-          <a:prstGeom prst="rect">
-            <a:avLst/>
-          </a:prstGeom>
-          <a:noFill/>
-          <a:ln/>
-        </p:spPr>
-        <p:txBody>
-          <a:bodyPr wrap="square" rtlCol="0" anchor="ctr"/>
-          <a:lstStyle/>
-          <a:p>
-            <a:pPr algn="ctr" indent="0" marL="0">
-              <a:buNone/>
-            </a:pPr>
-            <a:r>
-              <a:rPr lang="en-US" sz="1100" dirty="0">
-                <a:solidFill>
-                  <a:srgbClr val="5C9EAD"/>
+              <a:t>Residents Transitioned</a:t>
+            </a:r>
+            <a:endParaRPr lang="en-US" sz="1200" dirty="0"/>
+          </a:p>
+        </p:txBody>
+      </p:sp>
+      <p:sp>
+        <p:nvSpPr>
+          <p:cNvPr id="17" name="Text 14"/>
+          <p:cNvSpPr/>
+          <p:nvPr/>
+        </p:nvSpPr>
+        <p:spPr>
+          <a:xfrm>
+            <a:off x="5760720" y="2194560"/>
+            <a:ext cx="2468880" cy="457200"/>
+          </a:xfrm>
+          <a:prstGeom prst="rect">
+            <a:avLst/>
+          </a:prstGeom>
+          <a:noFill/>
+          <a:ln/>
+        </p:spPr>
+        <p:txBody>
+          <a:bodyPr wrap="square" rtlCol="0" anchor="ctr"/>
+          <a:lstStyle/>
+          <a:p>
+            <a:pPr indent="0" marL="0">
+              <a:buNone/>
+            </a:pPr>
+            <a:r>
+              <a:rPr lang="en-US" sz="1000" dirty="0">
+                <a:solidFill>
+                  <a:srgbClr val="5E7890"/>
                 </a:solidFill>
                 <a:latin typeface="Calibri" pitchFamily="34" charset="0"/>
                 <a:ea typeface="Calibri" pitchFamily="34" charset="-122"/>
                 <a:cs typeface="Calibri" pitchFamily="34" charset="-120"/>
               </a:rPr>
-              <a:t>Individuals transitioned through our housing program.</a:t>
-            </a:r>
-            <a:endParaRPr lang="en-US" sz="1100" dirty="0"/>
-          </a:p>
-        </p:txBody>
-      </p:sp>
-      <p:sp>
-        <p:nvSpPr>
-          <p:cNvPr id="12" name="Shape 9"/>
-          <p:cNvSpPr/>
-          <p:nvPr/>
-        </p:nvSpPr>
-        <p:spPr>
-          <a:xfrm>
-            <a:off x="6035040" y="1188720"/>
-            <a:ext cx="2377440" cy="3108960"/>
+              <a:t>Transitioned through housing program.</a:t>
+            </a:r>
+            <a:endParaRPr lang="en-US" sz="1000" dirty="0"/>
+          </a:p>
+        </p:txBody>
+      </p:sp>
+      <p:sp>
+        <p:nvSpPr>
+          <p:cNvPr id="18" name="Shape 15"/>
+          <p:cNvSpPr/>
+          <p:nvPr/>
+        </p:nvSpPr>
+        <p:spPr>
+          <a:xfrm>
+            <a:off x="5486400" y="2926080"/>
+            <a:ext cx="2926080" cy="1554480"/>
           </a:xfrm>
           <a:prstGeom prst="roundRect">
             <a:avLst>
-              <a:gd name="adj" fmla="val 3077"/>
+              <a:gd name="adj" fmla="val 4706"/>
             </a:avLst>
           </a:prstGeom>
           <a:solidFill>
-            <a:srgbClr val="E7ECEE"/>
+            <a:srgbClr val="FFFFFF"/>
           </a:solidFill>
           <a:ln w="12700">
             <a:solidFill>
-              <a:srgbClr val="B8D8E8"/>
+              <a:srgbClr val="E7ECEE"/>
             </a:solidFill>
             <a:prstDash val="solid"/>
           </a:ln>
-        </p:spPr>
-      </p:sp>
-      <p:sp>
-        <p:nvSpPr>
-          <p:cNvPr id="13" name="Text 10"/>
-          <p:cNvSpPr/>
-          <p:nvPr/>
-        </p:nvSpPr>
-        <p:spPr>
-          <a:xfrm>
-            <a:off x="6035040" y="1463040"/>
-            <a:ext cx="2377440" cy="822960"/>
-          </a:xfrm>
-          <a:prstGeom prst="rect">
-            <a:avLst/>
-          </a:prstGeom>
-          <a:noFill/>
-          <a:ln/>
-        </p:spPr>
-        <p:txBody>
-          <a:bodyPr wrap="square" rtlCol="0" anchor="ctr"/>
-          <a:lstStyle/>
-          <a:p>
-            <a:pPr algn="ctr" indent="0" marL="0">
-              <a:buNone/>
-            </a:pPr>
-            <a:r>
-              <a:rPr lang="en-US" sz="5400" b="1" dirty="0">
-                <a:solidFill>
-                  <a:srgbClr val="294C60"/>
+          <a:effectLst>
+            <a:outerShdw sx="100000" sy="100000" kx="0" ky="0" algn="bl" rotWithShape="0" blurRad="101600" dist="25400" dir="16200000">
+              <a:srgbClr val="294C60">
+                <a:alpha val="4000"/>
+              </a:srgbClr>
+            </a:outerShdw>
+          </a:effectLst>
+        </p:spPr>
+      </p:sp>
+      <p:sp>
+        <p:nvSpPr>
+          <p:cNvPr id="19" name="Shape 16"/>
+          <p:cNvSpPr/>
+          <p:nvPr/>
+        </p:nvSpPr>
+        <p:spPr>
+          <a:xfrm>
+            <a:off x="5486400" y="2926080"/>
+            <a:ext cx="73152" cy="1554480"/>
+          </a:xfrm>
+          <a:prstGeom prst="rect">
+            <a:avLst/>
+          </a:prstGeom>
+          <a:solidFill>
+            <a:srgbClr val="C86B4A"/>
+          </a:solidFill>
+          <a:ln/>
+        </p:spPr>
+      </p:sp>
+      <p:sp>
+        <p:nvSpPr>
+          <p:cNvPr id="20" name="Text 17"/>
+          <p:cNvSpPr/>
+          <p:nvPr/>
+        </p:nvSpPr>
+        <p:spPr>
+          <a:xfrm>
+            <a:off x="5760720" y="3017520"/>
+            <a:ext cx="2468880" cy="640080"/>
+          </a:xfrm>
+          <a:prstGeom prst="rect">
+            <a:avLst/>
+          </a:prstGeom>
+          <a:noFill/>
+          <a:ln/>
+        </p:spPr>
+        <p:txBody>
+          <a:bodyPr wrap="square" rtlCol="0" anchor="ctr"/>
+          <a:lstStyle/>
+          <a:p>
+            <a:pPr indent="0" marL="0">
+              <a:buNone/>
+            </a:pPr>
+            <a:r>
+              <a:rPr lang="en-US" sz="3600" b="1" dirty="0">
+                <a:solidFill>
+                  <a:srgbClr val="C86B4A"/>
                 </a:solidFill>
                 <a:latin typeface="Georgia" pitchFamily="34" charset="0"/>
                 <a:ea typeface="Georgia" pitchFamily="34" charset="-122"/>
@@ -3867,36 +5120,36 @@
               </a:rPr>
               <a:t>10K</a:t>
             </a:r>
-            <a:endParaRPr lang="en-US" sz="5400" dirty="0"/>
-          </a:p>
-        </p:txBody>
-      </p:sp>
-      <p:sp>
-        <p:nvSpPr>
-          <p:cNvPr id="14" name="Text 11"/>
-          <p:cNvSpPr/>
-          <p:nvPr/>
-        </p:nvSpPr>
-        <p:spPr>
-          <a:xfrm>
-            <a:off x="6035040" y="2468880"/>
-            <a:ext cx="2377440" cy="365760"/>
-          </a:xfrm>
-          <a:prstGeom prst="rect">
-            <a:avLst/>
-          </a:prstGeom>
-          <a:noFill/>
-          <a:ln/>
-        </p:spPr>
-        <p:txBody>
-          <a:bodyPr wrap="square" rtlCol="0" anchor="ctr"/>
-          <a:lstStyle/>
-          <a:p>
-            <a:pPr algn="ctr" indent="0" marL="0">
-              <a:buNone/>
-            </a:pPr>
-            <a:r>
-              <a:rPr lang="en-US" sz="1400" b="1" dirty="0">
+            <a:endParaRPr lang="en-US" sz="3600" dirty="0"/>
+          </a:p>
+        </p:txBody>
+      </p:sp>
+      <p:sp>
+        <p:nvSpPr>
+          <p:cNvPr id="21" name="Text 18"/>
+          <p:cNvSpPr/>
+          <p:nvPr/>
+        </p:nvSpPr>
+        <p:spPr>
+          <a:xfrm>
+            <a:off x="5760720" y="3657600"/>
+            <a:ext cx="2468880" cy="274320"/>
+          </a:xfrm>
+          <a:prstGeom prst="rect">
+            <a:avLst/>
+          </a:prstGeom>
+          <a:noFill/>
+          <a:ln/>
+        </p:spPr>
+        <p:txBody>
+          <a:bodyPr wrap="square" rtlCol="0" anchor="ctr"/>
+          <a:lstStyle/>
+          <a:p>
+            <a:pPr indent="0" marL="0">
+              <a:buNone/>
+            </a:pPr>
+            <a:r>
+              <a:rPr lang="en-US" sz="1200" b="1" dirty="0">
                 <a:solidFill>
                   <a:srgbClr val="27343B"/>
                 </a:solidFill>
@@ -3904,48 +5157,48 @@
                 <a:ea typeface="Calibri" pitchFamily="34" charset="-122"/>
                 <a:cs typeface="Calibri" pitchFamily="34" charset="-120"/>
               </a:rPr>
-              <a:t>Counseling Hours</a:t>
-            </a:r>
-            <a:endParaRPr lang="en-US" sz="1400" dirty="0"/>
-          </a:p>
-        </p:txBody>
-      </p:sp>
-      <p:sp>
-        <p:nvSpPr>
-          <p:cNvPr id="15" name="Text 12"/>
-          <p:cNvSpPr/>
-          <p:nvPr/>
-        </p:nvSpPr>
-        <p:spPr>
-          <a:xfrm>
-            <a:off x="6126480" y="2926080"/>
-            <a:ext cx="2194560" cy="914400"/>
-          </a:xfrm>
-          <a:prstGeom prst="rect">
-            <a:avLst/>
-          </a:prstGeom>
-          <a:noFill/>
-          <a:ln/>
-        </p:spPr>
-        <p:txBody>
-          <a:bodyPr wrap="square" rtlCol="0" anchor="ctr"/>
-          <a:lstStyle/>
-          <a:p>
-            <a:pPr algn="ctr" indent="0" marL="0">
-              <a:buNone/>
-            </a:pPr>
-            <a:r>
-              <a:rPr lang="en-US" sz="1100" dirty="0">
-                <a:solidFill>
-                  <a:srgbClr val="5C9EAD"/>
+              <a:t>Counseling &amp; Skills Hours</a:t>
+            </a:r>
+            <a:endParaRPr lang="en-US" sz="1200" dirty="0"/>
+          </a:p>
+        </p:txBody>
+      </p:sp>
+      <p:sp>
+        <p:nvSpPr>
+          <p:cNvPr id="22" name="Text 19"/>
+          <p:cNvSpPr/>
+          <p:nvPr/>
+        </p:nvSpPr>
+        <p:spPr>
+          <a:xfrm>
+            <a:off x="5760720" y="3931920"/>
+            <a:ext cx="2468880" cy="457200"/>
+          </a:xfrm>
+          <a:prstGeom prst="rect">
+            <a:avLst/>
+          </a:prstGeom>
+          <a:noFill/>
+          <a:ln/>
+        </p:spPr>
+        <p:txBody>
+          <a:bodyPr wrap="square" rtlCol="0" anchor="ctr"/>
+          <a:lstStyle/>
+          <a:p>
+            <a:pPr indent="0" marL="0">
+              <a:buNone/>
+            </a:pPr>
+            <a:r>
+              <a:rPr lang="en-US" sz="1000" dirty="0">
+                <a:solidFill>
+                  <a:srgbClr val="5E7890"/>
                 </a:solidFill>
                 <a:latin typeface="Calibri" pitchFamily="34" charset="0"/>
                 <a:ea typeface="Calibri" pitchFamily="34" charset="-122"/>
                 <a:cs typeface="Calibri" pitchFamily="34" charset="-120"/>
               </a:rPr>
-              <a:t>Behavioral and skills training hours completed.</a:t>
-            </a:r>
-            <a:endParaRPr lang="en-US" sz="1100" dirty="0"/>
+              <a:t>Total program counseling completed.</a:t>
+            </a:r>
+            <a:endParaRPr lang="en-US" sz="1000" dirty="0"/>
           </a:p>
         </p:txBody>
       </p:sp>
@@ -3989,16 +5242,23 @@
         </p:nvSpPr>
         <p:spPr>
           <a:xfrm>
-            <a:off x="0" y="5029200"/>
-            <a:ext cx="9144000" cy="114300"/>
-          </a:xfrm>
-          <a:prstGeom prst="rect">
-            <a:avLst/>
-          </a:prstGeom>
-          <a:solidFill>
-            <a:srgbClr val="C86B4A"/>
-          </a:solidFill>
-          <a:ln/>
+            <a:off x="365760" y="365760"/>
+            <a:ext cx="8412480" cy="4411980"/>
+          </a:xfrm>
+          <a:prstGeom prst="rect">
+            <a:avLst/>
+          </a:prstGeom>
+          <a:solidFill>
+            <a:srgbClr val="FFFFFF">
+              <a:alpha val="0"/>
+            </a:srgbClr>
+          </a:solidFill>
+          <a:ln w="12700">
+            <a:solidFill>
+              <a:srgbClr val="B8D8E8"/>
+            </a:solidFill>
+            <a:prstDash val="solid"/>
+          </a:ln>
         </p:spPr>
       </p:sp>
       <p:sp>
@@ -4010,23 +5270,23 @@
         <p:spPr>
           <a:xfrm>
             <a:off x="914400" y="1097280"/>
-            <a:ext cx="7315200" cy="365760"/>
-          </a:xfrm>
-          <a:prstGeom prst="rect">
-            <a:avLst/>
-          </a:prstGeom>
-          <a:noFill/>
-          <a:ln/>
-        </p:spPr>
-        <p:txBody>
-          <a:bodyPr wrap="square" rtlCol="0" anchor="ctr"/>
-          <a:lstStyle/>
-          <a:p>
-            <a:pPr algn="ctr" indent="0" marL="0">
-              <a:buNone/>
-            </a:pPr>
-            <a:r>
-              <a:rPr lang="en-US" sz="1600" b="1" spc="400" kern="0" dirty="0">
+            <a:ext cx="4114800" cy="365760"/>
+          </a:xfrm>
+          <a:prstGeom prst="rect">
+            <a:avLst/>
+          </a:prstGeom>
+          <a:noFill/>
+          <a:ln/>
+        </p:spPr>
+        <p:txBody>
+          <a:bodyPr wrap="square" rtlCol="0" anchor="ctr"/>
+          <a:lstStyle/>
+          <a:p>
+            <a:pPr indent="0" marL="0">
+              <a:buNone/>
+            </a:pPr>
+            <a:r>
+              <a:rPr lang="en-US" sz="1400" b="1" spc="400" kern="0" dirty="0">
                 <a:solidFill>
                   <a:srgbClr val="B8D8E8"/>
                 </a:solidFill>
@@ -4036,7 +5296,7 @@
               </a:rPr>
               <a:t>FAITH HAVEN HOUSE</a:t>
             </a:r>
-            <a:endParaRPr lang="en-US" sz="1600" dirty="0"/>
+            <a:endParaRPr lang="en-US" sz="1400" dirty="0"/>
           </a:p>
         </p:txBody>
       </p:sp>
@@ -4049,19 +5309,19 @@
         <p:spPr>
           <a:xfrm>
             <a:off x="914400" y="1554480"/>
-            <a:ext cx="7315200" cy="914400"/>
-          </a:xfrm>
-          <a:prstGeom prst="rect">
-            <a:avLst/>
-          </a:prstGeom>
-          <a:noFill/>
-          <a:ln/>
-        </p:spPr>
-        <p:txBody>
-          <a:bodyPr wrap="square" rtlCol="0" anchor="ctr"/>
-          <a:lstStyle/>
-          <a:p>
-            <a:pPr algn="ctr" indent="0" marL="0">
+            <a:ext cx="4114800" cy="731520"/>
+          </a:xfrm>
+          <a:prstGeom prst="rect">
+            <a:avLst/>
+          </a:prstGeom>
+          <a:noFill/>
+          <a:ln/>
+        </p:spPr>
+        <p:txBody>
+          <a:bodyPr wrap="square" rtlCol="0" anchor="ctr"/>
+          <a:lstStyle/>
+          <a:p>
+            <a:pPr indent="0" marL="0">
               <a:buNone/>
             </a:pPr>
             <a:r>
@@ -4087,20 +5347,20 @@
         </p:nvSpPr>
         <p:spPr>
           <a:xfrm>
-            <a:off x="914400" y="2468880"/>
-            <a:ext cx="7315200" cy="457200"/>
-          </a:xfrm>
-          <a:prstGeom prst="rect">
-            <a:avLst/>
-          </a:prstGeom>
-          <a:noFill/>
-          <a:ln/>
-        </p:spPr>
-        <p:txBody>
-          <a:bodyPr wrap="square" rtlCol="0" anchor="ctr"/>
-          <a:lstStyle/>
-          <a:p>
-            <a:pPr algn="ctr" indent="0" marL="0">
+            <a:off x="914400" y="2377440"/>
+            <a:ext cx="4114800" cy="731520"/>
+          </a:xfrm>
+          <a:prstGeom prst="rect">
+            <a:avLst/>
+          </a:prstGeom>
+          <a:noFill/>
+          <a:ln/>
+        </p:spPr>
+        <p:txBody>
+          <a:bodyPr wrap="square" rtlCol="0" anchor="ctr"/>
+          <a:lstStyle/>
+          <a:p>
+            <a:pPr indent="0" marL="0">
               <a:buNone/>
             </a:pPr>
             <a:r>
@@ -4112,54 +5372,15 @@
                 <a:ea typeface="Calibri" pitchFamily="34" charset="-122"/>
                 <a:cs typeface="Calibri" pitchFamily="34" charset="-120"/>
               </a:rPr>
-              <a:t>Join us in supporting self-sufficiency and restoration.</a:t>
+              <a:t>Partnering together to restore hope and rebuild self-sufficient lives.</a:t>
             </a:r>
             <a:endParaRPr lang="en-US" sz="1600" dirty="0"/>
-          </a:p>
-        </p:txBody>
-      </p:sp>
-      <p:sp>
-        <p:nvSpPr>
-          <p:cNvPr id="6" name="Text 4"/>
-          <p:cNvSpPr/>
-          <p:nvPr/>
-        </p:nvSpPr>
-        <p:spPr>
-          <a:xfrm>
-            <a:off x="914400" y="3200400"/>
-            <a:ext cx="7315200" cy="365760"/>
-          </a:xfrm>
-          <a:prstGeom prst="rect">
-            <a:avLst/>
-          </a:prstGeom>
-          <a:noFill/>
-          <a:ln/>
-        </p:spPr>
-        <p:txBody>
-          <a:bodyPr wrap="square" rtlCol="0" anchor="ctr"/>
-          <a:lstStyle/>
-          <a:p>
-            <a:pPr algn="ctr" indent="0" marL="0">
-              <a:buNone/>
-            </a:pPr>
-            <a:r>
-              <a:rPr lang="en-US" sz="1300" dirty="0">
-                <a:solidFill>
-                  <a:srgbClr val="FAF8EF"/>
-                </a:solidFill>
-                <a:latin typeface="Calibri" pitchFamily="34" charset="0"/>
-                <a:ea typeface="Calibri" pitchFamily="34" charset="-122"/>
-                <a:cs typeface="Calibri" pitchFamily="34" charset="-120"/>
-              </a:rPr>
-              <a:t>Website: www.faithhavenhouse.org   |   Email: info@faithhavenhouse.org</a:t>
-            </a:r>
-            <a:endParaRPr lang="en-US" sz="1300" dirty="0"/>
           </a:p>
         </p:txBody>
       </p:sp>
       <p:pic>
         <p:nvPicPr>
-          <p:cNvPr id="7" name="Image 0" descr="C:\Users\jlmil\OneDrive\Desktop\Faith Haven House\Faith Haven House Rebrand\fhh-website\public\assets\FHH-logo-clean.png">    </p:cNvPr>
+          <p:cNvPr id="6" name="Image 0" descr="C:\Users\jlmil\OneDrive\Desktop\Faith Haven House\Faith Haven House Rebrand\fhh-website\public\assets\FHH-logo-clean.png">    </p:cNvPr>
           <p:cNvPicPr>
             <a:picLocks noChangeAspect="1"/>
           </p:cNvPicPr>
@@ -4173,14 +5394,285 @@
         </p:blipFill>
         <p:spPr>
           <a:xfrm>
-            <a:off x="3566160" y="4023360"/>
-            <a:ext cx="2011680" cy="548640"/>
+            <a:off x="914400" y="3657600"/>
+            <a:ext cx="1645920" cy="457200"/>
           </a:xfrm>
           <a:prstGeom prst="rect">
             <a:avLst/>
           </a:prstGeom>
         </p:spPr>
       </p:pic>
+      <p:sp>
+        <p:nvSpPr>
+          <p:cNvPr id="7" name="Shape 4"/>
+          <p:cNvSpPr/>
+          <p:nvPr/>
+        </p:nvSpPr>
+        <p:spPr>
+          <a:xfrm>
+            <a:off x="5303520" y="914400"/>
+            <a:ext cx="2926080" cy="3291840"/>
+          </a:xfrm>
+          <a:prstGeom prst="roundRect">
+            <a:avLst>
+              <a:gd name="adj" fmla="val 2500"/>
+            </a:avLst>
+          </a:prstGeom>
+          <a:solidFill>
+            <a:srgbClr val="FAF8EF"/>
+          </a:solidFill>
+          <a:ln w="12700">
+            <a:solidFill>
+              <a:srgbClr val="5E7890"/>
+            </a:solidFill>
+            <a:prstDash val="solid"/>
+          </a:ln>
+          <a:effectLst>
+            <a:outerShdw sx="100000" sy="100000" kx="0" ky="0" algn="bl" rotWithShape="0" blurRad="152400" dist="50800" dir="16200000">
+              <a:srgbClr val="000000">
+                <a:alpha val="15000"/>
+              </a:srgbClr>
+            </a:outerShdw>
+          </a:effectLst>
+        </p:spPr>
+      </p:sp>
+      <p:sp>
+        <p:nvSpPr>
+          <p:cNvPr id="8" name="Shape 5"/>
+          <p:cNvSpPr/>
+          <p:nvPr/>
+        </p:nvSpPr>
+        <p:spPr>
+          <a:xfrm>
+            <a:off x="5303520" y="914400"/>
+            <a:ext cx="91440" cy="3291840"/>
+          </a:xfrm>
+          <a:prstGeom prst="rect">
+            <a:avLst/>
+          </a:prstGeom>
+          <a:solidFill>
+            <a:srgbClr val="C86B4A"/>
+          </a:solidFill>
+          <a:ln/>
+        </p:spPr>
+      </p:sp>
+      <p:sp>
+        <p:nvSpPr>
+          <p:cNvPr id="9" name="Text 6"/>
+          <p:cNvSpPr/>
+          <p:nvPr/>
+        </p:nvSpPr>
+        <p:spPr>
+          <a:xfrm>
+            <a:off x="5669280" y="1280160"/>
+            <a:ext cx="2286000" cy="365760"/>
+          </a:xfrm>
+          <a:prstGeom prst="rect">
+            <a:avLst/>
+          </a:prstGeom>
+          <a:noFill/>
+          <a:ln/>
+        </p:spPr>
+        <p:txBody>
+          <a:bodyPr wrap="square" rtlCol="0" anchor="ctr"/>
+          <a:lstStyle/>
+          <a:p>
+            <a:pPr indent="0" marL="0">
+              <a:buNone/>
+            </a:pPr>
+            <a:r>
+              <a:rPr lang="en-US" sz="1800" b="1" dirty="0">
+                <a:solidFill>
+                  <a:srgbClr val="294C60"/>
+                </a:solidFill>
+                <a:latin typeface="Georgia" pitchFamily="34" charset="0"/>
+                <a:ea typeface="Georgia" pitchFamily="34" charset="-122"/>
+                <a:cs typeface="Georgia" pitchFamily="34" charset="-120"/>
+              </a:rPr>
+              <a:t>Get in Touch</a:t>
+            </a:r>
+            <a:endParaRPr lang="en-US" sz="1800" dirty="0"/>
+          </a:p>
+        </p:txBody>
+      </p:sp>
+      <p:sp>
+        <p:nvSpPr>
+          <p:cNvPr id="10" name="Text 7"/>
+          <p:cNvSpPr/>
+          <p:nvPr/>
+        </p:nvSpPr>
+        <p:spPr>
+          <a:xfrm>
+            <a:off x="5669280" y="1828800"/>
+            <a:ext cx="2286000" cy="274320"/>
+          </a:xfrm>
+          <a:prstGeom prst="rect">
+            <a:avLst/>
+          </a:prstGeom>
+          <a:noFill/>
+          <a:ln/>
+        </p:spPr>
+        <p:txBody>
+          <a:bodyPr wrap="square" rtlCol="0" anchor="ctr"/>
+          <a:lstStyle/>
+          <a:p>
+            <a:pPr indent="0" marL="0">
+              <a:buNone/>
+            </a:pPr>
+            <a:r>
+              <a:rPr lang="en-US" sz="1200" dirty="0">
+                <a:solidFill>
+                  <a:srgbClr val="27343B"/>
+                </a:solidFill>
+                <a:latin typeface="Calibri" pitchFamily="34" charset="0"/>
+                <a:ea typeface="Calibri" pitchFamily="34" charset="-122"/>
+                <a:cs typeface="Calibri" pitchFamily="34" charset="-120"/>
+              </a:rPr>
+              <a:t>✉️  info@faithhavenhouse.org</a:t>
+            </a:r>
+            <a:endParaRPr lang="en-US" sz="1200" dirty="0"/>
+          </a:p>
+        </p:txBody>
+      </p:sp>
+      <p:sp>
+        <p:nvSpPr>
+          <p:cNvPr id="11" name="Text 8"/>
+          <p:cNvSpPr/>
+          <p:nvPr/>
+        </p:nvSpPr>
+        <p:spPr>
+          <a:xfrm>
+            <a:off x="5669280" y="2194560"/>
+            <a:ext cx="2286000" cy="274320"/>
+          </a:xfrm>
+          <a:prstGeom prst="rect">
+            <a:avLst/>
+          </a:prstGeom>
+          <a:noFill/>
+          <a:ln/>
+        </p:spPr>
+        <p:txBody>
+          <a:bodyPr wrap="square" rtlCol="0" anchor="ctr"/>
+          <a:lstStyle/>
+          <a:p>
+            <a:pPr indent="0" marL="0">
+              <a:buNone/>
+            </a:pPr>
+            <a:r>
+              <a:rPr lang="en-US" sz="1200" dirty="0">
+                <a:solidFill>
+                  <a:srgbClr val="27343B"/>
+                </a:solidFill>
+                <a:latin typeface="Calibri" pitchFamily="34" charset="0"/>
+                <a:ea typeface="Calibri" pitchFamily="34" charset="-122"/>
+                <a:cs typeface="Calibri" pitchFamily="34" charset="-120"/>
+              </a:rPr>
+              <a:t>🌐  www.faithhavenhouse.org</a:t>
+            </a:r>
+            <a:endParaRPr lang="en-US" sz="1200" dirty="0"/>
+          </a:p>
+        </p:txBody>
+      </p:sp>
+      <p:sp>
+        <p:nvSpPr>
+          <p:cNvPr id="12" name="Text 9"/>
+          <p:cNvSpPr/>
+          <p:nvPr/>
+        </p:nvSpPr>
+        <p:spPr>
+          <a:xfrm>
+            <a:off x="5669280" y="2560320"/>
+            <a:ext cx="2286000" cy="274320"/>
+          </a:xfrm>
+          <a:prstGeom prst="rect">
+            <a:avLst/>
+          </a:prstGeom>
+          <a:noFill/>
+          <a:ln/>
+        </p:spPr>
+        <p:txBody>
+          <a:bodyPr wrap="square" rtlCol="0" anchor="ctr"/>
+          <a:lstStyle/>
+          <a:p>
+            <a:pPr indent="0" marL="0">
+              <a:buNone/>
+            </a:pPr>
+            <a:r>
+              <a:rPr lang="en-US" sz="1200" dirty="0">
+                <a:solidFill>
+                  <a:srgbClr val="27343B"/>
+                </a:solidFill>
+                <a:latin typeface="Calibri" pitchFamily="34" charset="0"/>
+                <a:ea typeface="Calibri" pitchFamily="34" charset="-122"/>
+                <a:cs typeface="Calibri" pitchFamily="34" charset="-120"/>
+              </a:rPr>
+              <a:t>📞  (555) 019-2831</a:t>
+            </a:r>
+            <a:endParaRPr lang="en-US" sz="1200" dirty="0"/>
+          </a:p>
+        </p:txBody>
+      </p:sp>
+      <p:sp>
+        <p:nvSpPr>
+          <p:cNvPr id="13" name="Shape 10"/>
+          <p:cNvSpPr/>
+          <p:nvPr/>
+        </p:nvSpPr>
+        <p:spPr>
+          <a:xfrm>
+            <a:off x="5669280" y="3200400"/>
+            <a:ext cx="2194560" cy="457200"/>
+          </a:xfrm>
+          <a:prstGeom prst="roundRect">
+            <a:avLst>
+              <a:gd name="adj" fmla="val 12000"/>
+            </a:avLst>
+          </a:prstGeom>
+          <a:solidFill>
+            <a:srgbClr val="C86B4A"/>
+          </a:solidFill>
+          <a:ln/>
+        </p:spPr>
+      </p:sp>
+      <p:sp>
+        <p:nvSpPr>
+          <p:cNvPr id="14" name="Text 11"/>
+          <p:cNvSpPr/>
+          <p:nvPr/>
+        </p:nvSpPr>
+        <p:spPr>
+          <a:xfrm>
+            <a:off x="5669280" y="3200400"/>
+            <a:ext cx="2194560" cy="457200"/>
+          </a:xfrm>
+          <a:prstGeom prst="rect">
+            <a:avLst/>
+          </a:prstGeom>
+          <a:noFill/>
+          <a:ln/>
+        </p:spPr>
+        <p:txBody>
+          <a:bodyPr wrap="square" rtlCol="0" anchor="ctr"/>
+          <a:lstStyle/>
+          <a:p>
+            <a:pPr algn="ctr" indent="0" marL="0">
+              <a:buNone/>
+            </a:pPr>
+            <a:r>
+              <a:rPr lang="en-US" sz="1100" b="1" dirty="0">
+                <a:solidFill>
+                  <a:srgbClr val="FAF8EF"/>
+                </a:solidFill>
+                <a:latin typeface="Calibri" pitchFamily="34" charset="0"/>
+                <a:ea typeface="Calibri" pitchFamily="34" charset="-122"/>
+                <a:cs typeface="Calibri" pitchFamily="34" charset="-120"/>
+              </a:rPr>
+              <a:t>Visit Our Portal</a:t>
+            </a:r>
+            <a:endParaRPr lang="en-US" sz="1100" dirty="0"/>
+          </a:p>
+        </p:txBody>
+      </p:sp>
     </p:spTree>
   </p:cSld>
   <p:clrMapOvr>

</xml_diff>